<commit_message>
Add MKT1107 Buổi 9–10 slides; fix table column widths and break/reference layout
Co-Authored-By: Claude Opus 5.5 <noreply@anthropic.com>
Claude-Session: https://claude.ai/code/session_01Nw7HpGarY4JnDFYKKuarvZ
</commit_message>
<xml_diff>
--- a/mkt1107/output/MKT1107_W01_slides.pptx
+++ b/mkt1107/output/MKT1107_W01_slides.pptx
@@ -56,10 +56,9 @@
     <p:sldId id="304" r:id="rId50"/>
     <p:sldId id="305" r:id="rId51"/>
     <p:sldId id="306" r:id="rId52"/>
-    <p:sldId id="307" r:id="rId53"/>
   </p:sldIdLst>
   <p:notesMasterIdLst>
-    <p:notesMasterId r:id="rId54"/>
+    <p:notesMasterId r:id="rId53"/>
   </p:notesMasterIdLst>
   <p:sldSz cx="12192000" cy="6858000"/>
   <p:notesSz cx="6858000" cy="12192000"/>
@@ -158,14 +157,14 @@
   <p:extLst>
     <p:ext uri="{521415D9-36F7-43E2-AB2F-B90AF26B5E84}">
       <p14:sectionLst xmlns:p14="http://schemas.microsoft.com/office/powerpoint/2010/main">
-        <p14:section name="Mở đầu" id="{9c787b4d-45e9-aa47-dead-387b83000980}">
+        <p14:section name="Mở đầu" id="{b07c976e-84bb-f913-407c-ef3e7d454830}">
           <p14:sldIdLst>
             <p14:sldId id="256"/>
             <p14:sldId id="257"/>
             <p14:sldId id="258"/>
           </p14:sldIdLst>
         </p14:section>
-        <p14:section name="S2 · Giới thiệu học phần" id="{17a79aa0-1120-48a9-ab0f-55f258d972ae}">
+        <p14:section name="S2 · Giới thiệu học phần" id="{4944cf9c-d6b4-5834-6460-76346e36602b}">
           <p14:sldIdLst>
             <p14:sldId id="259"/>
             <p14:sldId id="260"/>
@@ -176,7 +175,7 @@
             <p14:sldId id="265"/>
           </p14:sldIdLst>
         </p14:section>
-        <p14:section name="S3 · Nghiên cứu marketing là gì, để làm gì, có những loại nào" id="{38d772a6-33eb-caf1-93df-38c12c59503b}">
+        <p14:section name="S3 · Nghiên cứu marketing là gì, để làm gì, có những loại nào" id="{299cda06-75b0-c573-7b67-0d6ecf081f4b}">
           <p14:sldIdLst>
             <p14:sldId id="266"/>
             <p14:sldId id="267"/>
@@ -204,7 +203,7 @@
             <p14:sldId id="289"/>
           </p14:sldIdLst>
         </p14:section>
-        <p14:section name="S5 · Tiến trình, đạo đức, hệ thống thông tin, người làm và người dùng" id="{215756c9-7f61-b2a7-b513-bb3f1dc4b65d}">
+        <p14:section name="S5 · Tiến trình, đạo đức, hệ thống thông tin, người làm và người dùng" id="{5297cef7-1f53-8820-649e-21274daf8b15}">
           <p14:sldIdLst>
             <p14:sldId id="290"/>
             <p14:sldId id="291"/>
@@ -219,19 +218,18 @@
             <p14:sldId id="300"/>
           </p14:sldIdLst>
         </p14:section>
-        <p14:section name="S7 · Thực hành nhóm" id="{6bf2097d-e9cc-3743-3237-ef5a8ffba136}">
+        <p14:section name="S7 · Thực hành nhóm" id="{f739681c-bff4-1855-0051-a86f58f8cb79}">
           <p14:sldIdLst>
             <p14:sldId id="301"/>
             <p14:sldId id="302"/>
           </p14:sldIdLst>
         </p14:section>
-        <p14:section name="S8 · Kết buổi" id="{25fff993-1aeb-4bcc-72bc-182fa33f84f2}">
+        <p14:section name="S8 · Kết buổi" id="{02794c00-c78c-ec0c-57f1-6ac62dd56a35}">
           <p14:sldIdLst>
             <p14:sldId id="303"/>
             <p14:sldId id="304"/>
             <p14:sldId id="305"/>
             <p14:sldId id="306"/>
-            <p14:sldId id="307"/>
           </p14:sldIdLst>
         </p14:section>
       </p14:sectionLst>
@@ -4894,94 +4892,6 @@
 </p:notes>
 </file>
 
-<file path=ppt/notesSlides/notesSlide52.xml><?xml version="1.0" encoding="utf-8"?>
-<p:notes xmlns:a="http://schemas.openxmlformats.org/drawingml/2006/main" xmlns:r="http://schemas.openxmlformats.org/officeDocument/2006/relationships" xmlns:p="http://schemas.openxmlformats.org/presentationml/2006/main">
-  <p:cSld>
-    <p:spTree>
-      <p:nvGrpSpPr>
-        <p:cNvPr id="1" name=""/>
-        <p:cNvGrpSpPr/>
-        <p:nvPr/>
-      </p:nvGrpSpPr>
-      <p:grpSpPr>
-        <a:xfrm>
-          <a:off x="0" y="0"/>
-          <a:ext cx="0" cy="0"/>
-          <a:chOff x="0" y="0"/>
-          <a:chExt cx="0" cy="0"/>
-        </a:xfrm>
-      </p:grpSpPr>
-      <p:sp>
-        <p:nvSpPr>
-          <p:cNvPr id="2" name="Slide Image Placeholder 1"/>
-          <p:cNvSpPr>
-            <a:spLocks noGrp="1" noRot="1" noChangeAspect="1"/>
-          </p:cNvSpPr>
-          <p:nvPr>
-            <p:ph type="sldImg"/>
-          </p:nvPr>
-        </p:nvSpPr>
-        <p:spPr/>
-      </p:sp>
-      <p:sp>
-        <p:nvSpPr>
-          <p:cNvPr id="3" name="Notes Placeholder 2"/>
-          <p:cNvSpPr>
-            <a:spLocks noGrp="1"/>
-          </p:cNvSpPr>
-          <p:nvPr>
-            <p:ph type="body" idx="1"/>
-          </p:nvPr>
-        </p:nvSpPr>
-        <p:spPr/>
-        <p:txBody>
-          <a:bodyPr/>
-          <a:lstStyle/>
-          <a:p>
-            <a:r>
-              <a:rPr lang="en-US" dirty="0"/>
-              <a:t>Tiếp danh mục tài liệu tham khảo.</a:t>
-            </a:r>
-            <a:endParaRPr lang="en-US" dirty="0"/>
-          </a:p>
-        </p:txBody>
-      </p:sp>
-      <p:sp>
-        <p:nvSpPr>
-          <p:cNvPr id="4" name="Slide Number Placeholder 3"/>
-          <p:cNvSpPr>
-            <a:spLocks noGrp="1"/>
-          </p:cNvSpPr>
-          <p:nvPr>
-            <p:ph type="sldNum" sz="quarter" idx="10"/>
-          </p:nvPr>
-        </p:nvSpPr>
-        <p:spPr/>
-        <p:txBody>
-          <a:bodyPr/>
-          <a:lstStyle/>
-          <a:p>
-            <a:fld id="{F7021451-1387-4CA6-816F-3879F97B5CBC}" type="slidenum">
-              <a:rPr lang="en-US"/>
-              <a:t>52</a:t>
-            </a:fld>
-            <a:endParaRPr lang="en-US"/>
-          </a:p>
-        </p:txBody>
-      </p:sp>
-    </p:spTree>
-    <p:extLst>
-      <p:ext uri="{BB962C8B-B14F-4D97-AF65-F5344CB8AC3E}">
-        <p14:creationId xmlns:p14="http://schemas.microsoft.com/office/powerpoint/2010/main" val="1024086991"/>
-      </p:ext>
-    </p:extLst>
-  </p:cSld>
-  <p:clrMapOvr>
-    <a:masterClrMapping/>
-  </p:clrMapOvr>
-</p:notes>
-</file>
-
 <file path=ppt/notesSlides/notesSlide6.xml><?xml version="1.0" encoding="utf-8"?>
 <p:notes xmlns:a="http://schemas.openxmlformats.org/drawingml/2006/main" xmlns:r="http://schemas.openxmlformats.org/officeDocument/2006/relationships" xmlns:p="http://schemas.openxmlformats.org/presentationml/2006/main">
   <p:cSld>
@@ -13402,9 +13312,9 @@
             <a:tbl>
               <a:tblPr/>
               <a:tblGrid>
-                <a:gridCol w="3688080"/>
-                <a:gridCol w="3688080"/>
-                <a:gridCol w="3688080"/>
+                <a:gridCol w="1835674"/>
+                <a:gridCol w="4388409"/>
+                <a:gridCol w="4840157"/>
               </a:tblGrid>
               <a:tr h="524256">
                 <a:tc>
@@ -18645,9 +18555,9 @@
             <a:tbl>
               <a:tblPr/>
               <a:tblGrid>
-                <a:gridCol w="3688080"/>
-                <a:gridCol w="3688080"/>
-                <a:gridCol w="3688080"/>
+                <a:gridCol w="2487163"/>
+                <a:gridCol w="4242571"/>
+                <a:gridCol w="4334505"/>
               </a:tblGrid>
               <a:tr h="524256">
                 <a:tc>
@@ -19294,7 +19204,7 @@
                   </a:tcPr>
                 </a:tc>
               </a:tr>
-              <a:tr h="920496">
+              <a:tr h="524256">
                 <a:tc>
                   <a:txBody>
                     <a:bodyPr/>
@@ -19724,7 +19634,7 @@
                   </a:tcPr>
                 </a:tc>
               </a:tr>
-              <a:tr h="524256">
+              <a:tr h="920496">
                 <a:tc>
                   <a:txBody>
                     <a:bodyPr/>
@@ -26731,7 +26641,7 @@
         <p:spPr>
           <a:xfrm>
             <a:off x="5943600" y="3566160"/>
-            <a:ext cx="5303520" cy="1463040"/>
+            <a:ext cx="4297680" cy="2011680"/>
           </a:xfrm>
           <a:prstGeom prst="rect">
             <a:avLst/>
@@ -34700,9 +34610,9 @@
             <a:tbl>
               <a:tblPr/>
               <a:tblGrid>
-                <a:gridCol w="3688080"/>
-                <a:gridCol w="3688080"/>
-                <a:gridCol w="3688080"/>
+                <a:gridCol w="3287379"/>
+                <a:gridCol w="3644968"/>
+                <a:gridCol w="4131893"/>
               </a:tblGrid>
               <a:tr h="524256">
                 <a:tc>
@@ -39937,7 +39847,7 @@
         </p:nvSpPr>
         <p:spPr>
           <a:xfrm>
-            <a:off x="585216" y="3425952"/>
+            <a:off x="585216" y="3389376"/>
             <a:ext cx="164592" cy="164592"/>
           </a:xfrm>
           <a:prstGeom prst="ellipse">
@@ -39957,7 +39867,7 @@
         </p:nvSpPr>
         <p:spPr>
           <a:xfrm>
-            <a:off x="914400" y="3233928"/>
+            <a:off x="914400" y="3197352"/>
             <a:ext cx="10607040" cy="944880"/>
           </a:xfrm>
           <a:prstGeom prst="rect">
@@ -40033,7 +39943,7 @@
         </p:nvSpPr>
         <p:spPr>
           <a:xfrm>
-            <a:off x="585216" y="4480560"/>
+            <a:off x="585216" y="4407408"/>
             <a:ext cx="164592" cy="164592"/>
           </a:xfrm>
           <a:prstGeom prst="ellipse">
@@ -40053,7 +39963,7 @@
         </p:nvSpPr>
         <p:spPr>
           <a:xfrm>
-            <a:off x="914400" y="4288536"/>
+            <a:off x="914400" y="4215384"/>
             <a:ext cx="10607040" cy="944880"/>
           </a:xfrm>
           <a:prstGeom prst="rect">
@@ -40116,6 +40026,102 @@
                 <a:cs typeface="Alexandria" pitchFamily="34" charset="-120"/>
               </a:rPr>
               <a:t> (7th ed.). Pearson.</a:t>
+            </a:r>
+            <a:endParaRPr lang="en-US" sz="2400" dirty="0"/>
+          </a:p>
+        </p:txBody>
+      </p:sp>
+      <p:sp>
+        <p:nvSpPr>
+          <p:cNvPr id="12" name="Dấu đầu dòng"/>
+          <p:cNvSpPr/>
+          <p:nvPr/>
+        </p:nvSpPr>
+        <p:spPr>
+          <a:xfrm>
+            <a:off x="585216" y="5425440"/>
+            <a:ext cx="164592" cy="164592"/>
+          </a:xfrm>
+          <a:prstGeom prst="ellipse">
+            <a:avLst/>
+          </a:prstGeom>
+          <a:solidFill>
+            <a:srgbClr val="49B296"/>
+          </a:solidFill>
+          <a:ln/>
+        </p:spPr>
+      </p:sp>
+      <p:sp>
+        <p:nvSpPr>
+          <p:cNvPr id="13" name="Text 11"/>
+          <p:cNvSpPr txBox="1"/>
+          <p:nvPr/>
+        </p:nvSpPr>
+        <p:spPr>
+          <a:xfrm>
+            <a:off x="914400" y="5233416"/>
+            <a:ext cx="10607040" cy="944880"/>
+          </a:xfrm>
+          <a:prstGeom prst="rect">
+            <a:avLst/>
+          </a:prstGeom>
+          <a:noFill/>
+          <a:ln/>
+        </p:spPr>
+        <p:txBody>
+          <a:bodyPr wrap="square" lIns="76200" tIns="76200" rIns="76200" bIns="76200" rtlCol="0" anchor="t"/>
+          <a:lstStyle/>
+          <a:p>
+            <a:pPr algn="l" indent="0" marL="0">
+              <a:lnSpc>
+                <a:spcPts val="3100"/>
+              </a:lnSpc>
+              <a:buNone/>
+            </a:pPr>
+            <a:r>
+              <a:rPr lang="en-US" sz="2400" dirty="0">
+                <a:solidFill>
+                  <a:srgbClr val="2E2A3A"/>
+                </a:solidFill>
+                <a:latin typeface="Alexandria" pitchFamily="34" charset="0"/>
+                <a:ea typeface="Alexandria" pitchFamily="34" charset="-122"/>
+                <a:cs typeface="Alexandria" pitchFamily="34" charset="-120"/>
+              </a:rPr>
+              <a:t>Nguyễn, Đ. T., &amp; Nguyễn, T. M. T. (2015). </a:t>
+            </a:r>
+            <a:pPr algn="l" indent="0" marL="0">
+              <a:lnSpc>
+                <a:spcPts val="3100"/>
+              </a:lnSpc>
+              <a:buNone/>
+            </a:pPr>
+            <a:r>
+              <a:rPr lang="en-US" sz="2400" i="1" dirty="0">
+                <a:solidFill>
+                  <a:srgbClr val="2E2A3A"/>
+                </a:solidFill>
+                <a:latin typeface="Alexandria" pitchFamily="34" charset="0"/>
+                <a:ea typeface="Alexandria" pitchFamily="34" charset="-122"/>
+                <a:cs typeface="Alexandria" pitchFamily="34" charset="-120"/>
+              </a:rPr>
+              <a:t>Giáo trình nghiên cứu thị trường</a:t>
+            </a:r>
+            <a:pPr algn="l" indent="0" marL="0">
+              <a:lnSpc>
+                <a:spcPts val="3100"/>
+              </a:lnSpc>
+              <a:buNone/>
+            </a:pPr>
+            <a:r>
+              <a:rPr lang="en-US" sz="2400" dirty="0">
+                <a:solidFill>
+                  <a:srgbClr val="2E2A3A"/>
+                </a:solidFill>
+                <a:latin typeface="Alexandria" pitchFamily="34" charset="0"/>
+                <a:ea typeface="Alexandria" pitchFamily="34" charset="-122"/>
+                <a:cs typeface="Alexandria" pitchFamily="34" charset="-120"/>
+              </a:rPr>
+              <a:t>. Nhà xuất bản Kinh tế TP. Hồ Chí Minh.</a:t>
             </a:r>
             <a:endParaRPr lang="en-US" sz="2400" dirty="0"/>
           </a:p>
@@ -40164,276 +40170,6 @@
             <a:fld id="{F7021451-1387-4CA6-816F-3879F97B5CBC}" type="slidenum">
               <a:rPr b="0" lang="en-US"/>
               <a:t>51</a:t>
-            </a:fld>
-            <a:endParaRPr lang="en-US"/>
-          </a:p>
-        </p:txBody>
-      </p:sp>
-    </p:spTree>
-  </p:cSld>
-  <p:clrMapOvr>
-    <a:masterClrMapping/>
-  </p:clrMapOvr>
-</p:sld>
-</file>
-
-<file path=ppt/slides/slide52.xml><?xml version="1.0" encoding="utf-8"?>
-<p:sld xmlns:a="http://schemas.openxmlformats.org/drawingml/2006/main" xmlns:r="http://schemas.openxmlformats.org/officeDocument/2006/relationships" xmlns:p="http://schemas.openxmlformats.org/presentationml/2006/main">
-  <p:cSld name="Slide 52">
-    <p:spTree>
-      <p:nvGrpSpPr>
-        <p:cNvPr id="1" name=""/>
-        <p:cNvGrpSpPr/>
-        <p:nvPr/>
-      </p:nvGrpSpPr>
-      <p:grpSpPr>
-        <a:xfrm>
-          <a:off x="0" y="0"/>
-          <a:ext cx="0" cy="0"/>
-          <a:chOff x="0" y="0"/>
-          <a:chExt cx="0" cy="0"/>
-        </a:xfrm>
-      </p:grpSpPr>
-      <p:sp>
-        <p:nvSpPr>
-          <p:cNvPr id="2" name="Trang trí"/>
-          <p:cNvSpPr/>
-          <p:nvPr/>
-        </p:nvSpPr>
-        <p:spPr>
-          <a:xfrm>
-            <a:off x="11460175" y="-731520"/>
-            <a:ext cx="1463040" cy="1463040"/>
-          </a:xfrm>
-          <a:prstGeom prst="ellipse">
-            <a:avLst/>
-          </a:prstGeom>
-          <a:solidFill>
-            <a:srgbClr val="962B7C"/>
-          </a:solidFill>
-          <a:ln/>
-        </p:spPr>
-      </p:sp>
-      <p:sp>
-        <p:nvSpPr>
-          <p:cNvPr id="3" name="Trang trí"/>
-          <p:cNvSpPr/>
-          <p:nvPr/>
-        </p:nvSpPr>
-        <p:spPr>
-          <a:xfrm>
-            <a:off x="11505895" y="868680"/>
-            <a:ext cx="274320" cy="274320"/>
-          </a:xfrm>
-          <a:prstGeom prst="ellipse">
-            <a:avLst/>
-          </a:prstGeom>
-          <a:solidFill>
-            <a:srgbClr val="49B296"/>
-          </a:solidFill>
-          <a:ln/>
-        </p:spPr>
-      </p:sp>
-      <p:sp>
-        <p:nvSpPr>
-          <p:cNvPr id="4" name="Trang trí"/>
-          <p:cNvSpPr/>
-          <p:nvPr/>
-        </p:nvSpPr>
-        <p:spPr>
-          <a:xfrm>
-            <a:off x="-457200" y="6400800"/>
-            <a:ext cx="914400" cy="914400"/>
-          </a:xfrm>
-          <a:prstGeom prst="ellipse">
-            <a:avLst/>
-          </a:prstGeom>
-          <a:solidFill>
-            <a:srgbClr val="09A1E5"/>
-          </a:solidFill>
-          <a:ln/>
-        </p:spPr>
-      </p:sp>
-      <p:sp>
-        <p:nvSpPr>
-          <p:cNvPr id="5" name="Text 0"/>
-          <p:cNvSpPr/>
-          <p:nvPr>
-            <p:ph idx="100" type="title" hasCustomPrompt="1"/>
-          </p:nvPr>
-        </p:nvSpPr>
-        <p:spPr>
-          <a:xfrm>
-            <a:off x="548640" y="365760"/>
-            <a:ext cx="10789920" cy="1280160"/>
-          </a:xfrm>
-          <a:prstGeom prst="rect">
-            <a:avLst/>
-          </a:prstGeom>
-          <a:noFill/>
-          <a:ln/>
-        </p:spPr>
-        <p:txBody>
-          <a:bodyPr wrap="square" lIns="76200" tIns="76200" rIns="76200" bIns="76200" rtlCol="0" anchor="t"/>
-          <a:lstStyle/>
-          <a:p>
-            <a:pPr algn="l" indent="0" marL="0">
-              <a:buNone/>
-            </a:pPr>
-            <a:r>
-              <a:rPr lang="en-US" sz="3600" b="1" dirty="0">
-                <a:solidFill>
-                  <a:srgbClr val="2E2A3A"/>
-                </a:solidFill>
-                <a:latin typeface="Alexandria" pitchFamily="34" charset="0"/>
-                <a:ea typeface="Alexandria" pitchFamily="34" charset="-122"/>
-                <a:cs typeface="Alexandria" pitchFamily="34" charset="-120"/>
-              </a:rPr>
-              <a:t>Tài liệu tham khảo (tiếp)</a:t>
-            </a:r>
-            <a:endParaRPr lang="en-US" sz="3600" dirty="0"/>
-          </a:p>
-        </p:txBody>
-      </p:sp>
-      <p:sp>
-        <p:nvSpPr>
-          <p:cNvPr id="6" name="Dấu đầu dòng"/>
-          <p:cNvSpPr/>
-          <p:nvPr/>
-        </p:nvSpPr>
-        <p:spPr>
-          <a:xfrm>
-            <a:off x="585216" y="1975104"/>
-            <a:ext cx="164592" cy="164592"/>
-          </a:xfrm>
-          <a:prstGeom prst="ellipse">
-            <a:avLst/>
-          </a:prstGeom>
-          <a:solidFill>
-            <a:srgbClr val="962B7C"/>
-          </a:solidFill>
-          <a:ln/>
-        </p:spPr>
-      </p:sp>
-      <p:sp>
-        <p:nvSpPr>
-          <p:cNvPr id="7" name="Text 5"/>
-          <p:cNvSpPr txBox="1"/>
-          <p:nvPr/>
-        </p:nvSpPr>
-        <p:spPr>
-          <a:xfrm>
-            <a:off x="914400" y="1783080"/>
-            <a:ext cx="10607040" cy="944880"/>
-          </a:xfrm>
-          <a:prstGeom prst="rect">
-            <a:avLst/>
-          </a:prstGeom>
-          <a:noFill/>
-          <a:ln/>
-        </p:spPr>
-        <p:txBody>
-          <a:bodyPr wrap="square" lIns="76200" tIns="76200" rIns="76200" bIns="76200" rtlCol="0" anchor="t"/>
-          <a:lstStyle/>
-          <a:p>
-            <a:pPr algn="l" indent="0" marL="0">
-              <a:lnSpc>
-                <a:spcPts val="3100"/>
-              </a:lnSpc>
-              <a:buNone/>
-            </a:pPr>
-            <a:r>
-              <a:rPr lang="en-US" sz="2400" dirty="0">
-                <a:solidFill>
-                  <a:srgbClr val="2E2A3A"/>
-                </a:solidFill>
-                <a:latin typeface="Alexandria" pitchFamily="34" charset="0"/>
-                <a:ea typeface="Alexandria" pitchFamily="34" charset="-122"/>
-                <a:cs typeface="Alexandria" pitchFamily="34" charset="-120"/>
-              </a:rPr>
-              <a:t>Nguyễn, Đ. T., &amp; Nguyễn, T. M. T. (2015). </a:t>
-            </a:r>
-            <a:pPr algn="l" indent="0" marL="0">
-              <a:lnSpc>
-                <a:spcPts val="3100"/>
-              </a:lnSpc>
-              <a:buNone/>
-            </a:pPr>
-            <a:r>
-              <a:rPr lang="en-US" sz="2400" i="1" dirty="0">
-                <a:solidFill>
-                  <a:srgbClr val="2E2A3A"/>
-                </a:solidFill>
-                <a:latin typeface="Alexandria" pitchFamily="34" charset="0"/>
-                <a:ea typeface="Alexandria" pitchFamily="34" charset="-122"/>
-                <a:cs typeface="Alexandria" pitchFamily="34" charset="-120"/>
-              </a:rPr>
-              <a:t>Giáo trình nghiên cứu thị trường</a:t>
-            </a:r>
-            <a:pPr algn="l" indent="0" marL="0">
-              <a:lnSpc>
-                <a:spcPts val="3100"/>
-              </a:lnSpc>
-              <a:buNone/>
-            </a:pPr>
-            <a:r>
-              <a:rPr lang="en-US" sz="2400" dirty="0">
-                <a:solidFill>
-                  <a:srgbClr val="2E2A3A"/>
-                </a:solidFill>
-                <a:latin typeface="Alexandria" pitchFamily="34" charset="0"/>
-                <a:ea typeface="Alexandria" pitchFamily="34" charset="-122"/>
-                <a:cs typeface="Alexandria" pitchFamily="34" charset="-120"/>
-              </a:rPr>
-              <a:t>. Nhà xuất bản Kinh tế TP. Hồ Chí Minh.</a:t>
-            </a:r>
-            <a:endParaRPr lang="en-US" sz="2400" dirty="0"/>
-          </a:p>
-        </p:txBody>
-      </p:sp>
-      <p:sp>
-        <p:nvSpPr>
-          <p:cNvPr id="25" name="Slide Number Placeholder 0"/>
-          <p:cNvSpPr>
-            <a:spLocks noGrp="1"/>
-          </p:cNvSpPr>
-          <p:nvPr>
-            <p:ph type="sldNum" sz="quarter" idx="4294967295"/>
-          </p:nvPr>
-        </p:nvSpPr>
-        <p:spPr>
-          <a:xfrm>
-            <a:off x="10881360" y="6263640"/>
-            <a:ext cx="914400" cy="457200"/>
-          </a:xfrm>
-          <a:prstGeom prst="rect">
-            <a:avLst/>
-          </a:prstGeom>
-          <a:extLst>
-            <a:ext uri="{C572A759-6A51-4108-AA02-DFA0A04FC94B}">
-              <ma14:wrappingTextBoxFlag xmlns:ma14="http://schemas.microsoft.com/office/mac/drawingml/2011/main" val="0"/>
-            </a:ext>
-          </a:extLst>
-        </p:spPr>
-        <p:txBody>
-          <a:bodyPr/>
-          <a:lstStyle>
-            <a:lvl1pPr>
-              <a:defRPr sz="2400">
-                <a:solidFill>
-                  <a:srgbClr val="5B5668"/>
-                </a:solidFill>
-                <a:latin typeface="Alexandria"/>
-                <a:ea typeface="Alexandria"/>
-                <a:cs typeface="Alexandria"/>
-              </a:defRPr>
-            </a:lvl1pPr>
-          </a:lstStyle>
-          <a:p>
-            <a:pPr algn="r"/>
-            <a:fld id="{F7021451-1387-4CA6-816F-3879F97B5CBC}" type="slidenum">
-              <a:rPr b="0" lang="en-US"/>
-              <a:t>52</a:t>
             </a:fld>
             <a:endParaRPr lang="en-US"/>
           </a:p>
@@ -41183,8 +40919,8 @@
             <a:tbl>
               <a:tblPr/>
               <a:tblGrid>
-                <a:gridCol w="5532120"/>
-                <a:gridCol w="5532120"/>
+                <a:gridCol w="5229031"/>
+                <a:gridCol w="5835209"/>
               </a:tblGrid>
               <a:tr h="524256">
                 <a:tc>
@@ -42040,7 +41776,7 @@
         </p:nvSpPr>
         <p:spPr>
           <a:xfrm>
-            <a:off x="548640" y="5294376"/>
+            <a:off x="548640" y="5394960"/>
             <a:ext cx="11064240" cy="685800"/>
           </a:xfrm>
           <a:prstGeom prst="roundRect">
@@ -42062,7 +41798,7 @@
         </p:nvSpPr>
         <p:spPr>
           <a:xfrm>
-            <a:off x="731520" y="5408676"/>
+            <a:off x="731520" y="5509260"/>
             <a:ext cx="457200" cy="457200"/>
           </a:xfrm>
           <a:prstGeom prst="ellipse">
@@ -42082,7 +41818,7 @@
         </p:nvSpPr>
         <p:spPr>
           <a:xfrm>
-            <a:off x="731520" y="5408676"/>
+            <a:off x="731520" y="5509260"/>
             <a:ext cx="457200" cy="457200"/>
           </a:xfrm>
           <a:prstGeom prst="rect">
@@ -42121,7 +41857,7 @@
         </p:nvSpPr>
         <p:spPr>
           <a:xfrm>
-            <a:off x="1325880" y="5294376"/>
+            <a:off x="1325880" y="5394960"/>
             <a:ext cx="10149840" cy="685800"/>
           </a:xfrm>
           <a:prstGeom prst="rect">

</xml_diff>

<commit_message>
Add MKT1107 Buổi 3–4 slides; fix nested markup and label sizing in builder
Co-Authored-By: Claude Opus 5.5 <noreply@anthropic.com>
Claude-Session: https://claude.ai/code/session_01Nw7HpGarY4JnDFYKKuarvZ
</commit_message>
<xml_diff>
--- a/mkt1107/output/MKT1107_W01_slides.pptx
+++ b/mkt1107/output/MKT1107_W01_slides.pptx
@@ -157,14 +157,14 @@
   <p:extLst>
     <p:ext uri="{521415D9-36F7-43E2-AB2F-B90AF26B5E84}">
       <p14:sectionLst xmlns:p14="http://schemas.microsoft.com/office/powerpoint/2010/main">
-        <p14:section name="Mở đầu" id="{b07c976e-84bb-f913-407c-ef3e7d454830}">
+        <p14:section name="Mở đầu" id="{37ba2e1e-05fb-e03f-651d-76539f1f7635}">
           <p14:sldIdLst>
             <p14:sldId id="256"/>
             <p14:sldId id="257"/>
             <p14:sldId id="258"/>
           </p14:sldIdLst>
         </p14:section>
-        <p14:section name="S2 · Giới thiệu học phần" id="{4944cf9c-d6b4-5834-6460-76346e36602b}">
+        <p14:section name="S2 · Giới thiệu học phần" id="{8f54aa9d-b60e-9289-4170-4d81ebac86bc}">
           <p14:sldIdLst>
             <p14:sldId id="259"/>
             <p14:sldId id="260"/>
@@ -175,7 +175,7 @@
             <p14:sldId id="265"/>
           </p14:sldIdLst>
         </p14:section>
-        <p14:section name="S3 · Nghiên cứu marketing là gì, để làm gì, có những loại nào" id="{299cda06-75b0-c573-7b67-0d6ecf081f4b}">
+        <p14:section name="S3 · Nghiên cứu marketing là gì, để làm gì, có những loại nào" id="{b28dbaee-4fd9-b62f-517c-a8f2e2ec2de1}">
           <p14:sldIdLst>
             <p14:sldId id="266"/>
             <p14:sldId id="267"/>
@@ -203,7 +203,7 @@
             <p14:sldId id="289"/>
           </p14:sldIdLst>
         </p14:section>
-        <p14:section name="S5 · Tiến trình, đạo đức, hệ thống thông tin, người làm và người dùng" id="{5297cef7-1f53-8820-649e-21274daf8b15}">
+        <p14:section name="S5 · Tiến trình, đạo đức, hệ thống thông tin, người làm và người dùng" id="{f8392533-bfa2-6679-9ac0-9320083ed60c}">
           <p14:sldIdLst>
             <p14:sldId id="290"/>
             <p14:sldId id="291"/>
@@ -218,13 +218,13 @@
             <p14:sldId id="300"/>
           </p14:sldIdLst>
         </p14:section>
-        <p14:section name="S7 · Thực hành nhóm" id="{f739681c-bff4-1855-0051-a86f58f8cb79}">
+        <p14:section name="S7 · Thực hành nhóm" id="{ba1cf02f-bdfd-7aac-dff3-1081a710dfd7}">
           <p14:sldIdLst>
             <p14:sldId id="301"/>
             <p14:sldId id="302"/>
           </p14:sldIdLst>
         </p14:section>
-        <p14:section name="S8 · Kết buổi" id="{02794c00-c78c-ec0c-57f1-6ac62dd56a35}">
+        <p14:section name="S8 · Kết buổi" id="{12f31812-b057-ef94-798a-38b0f197b302}">
           <p14:sldIdLst>
             <p14:sldId id="303"/>
             <p14:sldId id="304"/>
@@ -21015,7 +21015,7 @@
         <p:spPr>
           <a:xfrm>
             <a:off x="777240" y="2011680"/>
-            <a:ext cx="2377440" cy="566928"/>
+            <a:ext cx="2400910" cy="566928"/>
           </a:xfrm>
           <a:prstGeom prst="roundRect">
             <a:avLst>
@@ -21037,7 +21037,7 @@
         <p:spPr>
           <a:xfrm>
             <a:off x="777240" y="2011680"/>
-            <a:ext cx="2377440" cy="566928"/>
+            <a:ext cx="2400910" cy="566928"/>
           </a:xfrm>
           <a:prstGeom prst="rect">
             <a:avLst/>
@@ -21443,7 +21443,7 @@
         <p:spPr>
           <a:xfrm>
             <a:off x="777240" y="2011680"/>
-            <a:ext cx="2377440" cy="566928"/>
+            <a:ext cx="2462174" cy="566928"/>
           </a:xfrm>
           <a:prstGeom prst="roundRect">
             <a:avLst>
@@ -21465,7 +21465,7 @@
         <p:spPr>
           <a:xfrm>
             <a:off x="777240" y="2011680"/>
-            <a:ext cx="2377440" cy="566928"/>
+            <a:ext cx="2462174" cy="566928"/>
           </a:xfrm>
           <a:prstGeom prst="rect">
             <a:avLst/>
@@ -21871,7 +21871,7 @@
         <p:spPr>
           <a:xfrm>
             <a:off x="777240" y="2011680"/>
-            <a:ext cx="2377440" cy="566928"/>
+            <a:ext cx="2461565" cy="566928"/>
           </a:xfrm>
           <a:prstGeom prst="roundRect">
             <a:avLst>
@@ -21893,7 +21893,7 @@
         <p:spPr>
           <a:xfrm>
             <a:off x="777240" y="2011680"/>
-            <a:ext cx="2377440" cy="566928"/>
+            <a:ext cx="2461565" cy="566928"/>
           </a:xfrm>
           <a:prstGeom prst="rect">
             <a:avLst/>
@@ -23091,7 +23091,7 @@
         <p:spPr>
           <a:xfrm>
             <a:off x="777240" y="2011680"/>
-            <a:ext cx="2377440" cy="566928"/>
+            <a:ext cx="2462784" cy="566928"/>
           </a:xfrm>
           <a:prstGeom prst="roundRect">
             <a:avLst>
@@ -23113,7 +23113,7 @@
         <p:spPr>
           <a:xfrm>
             <a:off x="777240" y="2011680"/>
-            <a:ext cx="2377440" cy="566928"/>
+            <a:ext cx="2462784" cy="566928"/>
           </a:xfrm>
           <a:prstGeom prst="rect">
             <a:avLst/>
@@ -23519,7 +23519,7 @@
         <p:spPr>
           <a:xfrm>
             <a:off x="777240" y="2011680"/>
-            <a:ext cx="2377440" cy="566928"/>
+            <a:ext cx="2468270" cy="566928"/>
           </a:xfrm>
           <a:prstGeom prst="roundRect">
             <a:avLst>
@@ -23541,7 +23541,7 @@
         <p:spPr>
           <a:xfrm>
             <a:off x="777240" y="2011680"/>
-            <a:ext cx="2377440" cy="566928"/>
+            <a:ext cx="2468270" cy="566928"/>
           </a:xfrm>
           <a:prstGeom prst="rect">
             <a:avLst/>
@@ -23947,7 +23947,7 @@
         <p:spPr>
           <a:xfrm>
             <a:off x="777240" y="2011680"/>
-            <a:ext cx="2377440" cy="566928"/>
+            <a:ext cx="2469794" cy="566928"/>
           </a:xfrm>
           <a:prstGeom prst="roundRect">
             <a:avLst>
@@ -23969,7 +23969,7 @@
         <p:spPr>
           <a:xfrm>
             <a:off x="777240" y="2011680"/>
-            <a:ext cx="2377440" cy="566928"/>
+            <a:ext cx="2469794" cy="566928"/>
           </a:xfrm>
           <a:prstGeom prst="rect">
             <a:avLst/>

</xml_diff>

<commit_message>
Add MKT1107 Buổi 7–8 slides; builder: keep NBSP words together, escaped asterisks
Co-Authored-By: Claude Opus 5.5 <noreply@anthropic.com>
Claude-Session: https://claude.ai/code/session_01Nw7HpGarY4JnDFYKKuarvZ
</commit_message>
<xml_diff>
--- a/mkt1107/output/MKT1107_W01_slides.pptx
+++ b/mkt1107/output/MKT1107_W01_slides.pptx
@@ -157,14 +157,14 @@
   <p:extLst>
     <p:ext uri="{521415D9-36F7-43E2-AB2F-B90AF26B5E84}">
       <p14:sectionLst xmlns:p14="http://schemas.microsoft.com/office/powerpoint/2010/main">
-        <p14:section name="Mở đầu" id="{37ba2e1e-05fb-e03f-651d-76539f1f7635}">
+        <p14:section name="Mở đầu" id="{0976a9e9-5bca-f048-db39-45dbecbe6f14}">
           <p14:sldIdLst>
             <p14:sldId id="256"/>
             <p14:sldId id="257"/>
             <p14:sldId id="258"/>
           </p14:sldIdLst>
         </p14:section>
-        <p14:section name="S2 · Giới thiệu học phần" id="{8f54aa9d-b60e-9289-4170-4d81ebac86bc}">
+        <p14:section name="S2 · Giới thiệu học phần" id="{ae5abfd3-c93c-f278-7fa6-3a20e3f8c2a4}">
           <p14:sldIdLst>
             <p14:sldId id="259"/>
             <p14:sldId id="260"/>
@@ -175,7 +175,7 @@
             <p14:sldId id="265"/>
           </p14:sldIdLst>
         </p14:section>
-        <p14:section name="S3 · Nghiên cứu marketing là gì, để làm gì, có những loại nào" id="{b28dbaee-4fd9-b62f-517c-a8f2e2ec2de1}">
+        <p14:section name="S3 · Nghiên cứu marketing là gì, để làm gì, có những loại nào" id="{41394684-77cd-ee9f-d401-e730791bfb3e}">
           <p14:sldIdLst>
             <p14:sldId id="266"/>
             <p14:sldId id="267"/>
@@ -203,7 +203,7 @@
             <p14:sldId id="289"/>
           </p14:sldIdLst>
         </p14:section>
-        <p14:section name="S5 · Tiến trình, đạo đức, hệ thống thông tin, người làm và người dùng" id="{f8392533-bfa2-6679-9ac0-9320083ed60c}">
+        <p14:section name="S5 · Tiến trình, đạo đức, hệ thống thông tin, người làm và người dùng" id="{1869110e-3d04-0eae-37f7-8f9d5cd96592}">
           <p14:sldIdLst>
             <p14:sldId id="290"/>
             <p14:sldId id="291"/>
@@ -218,13 +218,13 @@
             <p14:sldId id="300"/>
           </p14:sldIdLst>
         </p14:section>
-        <p14:section name="S7 · Thực hành nhóm" id="{ba1cf02f-bdfd-7aac-dff3-1081a710dfd7}">
+        <p14:section name="S7 · Thực hành nhóm" id="{44ff38bd-c394-ccb7-71c7-0fe0071cef0d}">
           <p14:sldIdLst>
             <p14:sldId id="301"/>
             <p14:sldId id="302"/>
           </p14:sldIdLst>
         </p14:section>
-        <p14:section name="S8 · Kết buổi" id="{12f31812-b057-ef94-798a-38b0f197b302}">
+        <p14:section name="S8 · Kết buổi" id="{a4b856b7-dfe4-6711-5414-ca9de95c18e5}">
           <p14:sldIdLst>
             <p14:sldId id="303"/>
             <p14:sldId id="304"/>

</xml_diff>

<commit_message>
WIP: final visual polish for MKT1107 Buổi 1–4, 8–10
Co-Authored-By: Claude Opus 5.5 <noreply@anthropic.com>
Claude-Session: https://claude.ai/code/session_01Nw7HpGarY4JnDFYKKuarvZ
</commit_message>
<xml_diff>
--- a/mkt1107/output/MKT1107_W01_slides.pptx
+++ b/mkt1107/output/MKT1107_W01_slides.pptx
@@ -157,14 +157,14 @@
   <p:extLst>
     <p:ext uri="{521415D9-36F7-43E2-AB2F-B90AF26B5E84}">
       <p14:sectionLst xmlns:p14="http://schemas.microsoft.com/office/powerpoint/2010/main">
-        <p14:section name="Mở đầu" id="{0976a9e9-5bca-f048-db39-45dbecbe6f14}">
+        <p14:section name="Mở đầu" id="{213382eb-28df-c24e-356b-1dff0342f390}">
           <p14:sldIdLst>
             <p14:sldId id="256"/>
             <p14:sldId id="257"/>
             <p14:sldId id="258"/>
           </p14:sldIdLst>
         </p14:section>
-        <p14:section name="S2 · Giới thiệu học phần" id="{ae5abfd3-c93c-f278-7fa6-3a20e3f8c2a4}">
+        <p14:section name="S2 · Giới thiệu học phần" id="{18404e0f-82f9-4e98-2953-787fb0aa6402}">
           <p14:sldIdLst>
             <p14:sldId id="259"/>
             <p14:sldId id="260"/>
@@ -175,7 +175,7 @@
             <p14:sldId id="265"/>
           </p14:sldIdLst>
         </p14:section>
-        <p14:section name="S3 · Nghiên cứu marketing là gì, để làm gì, có những loại nào" id="{41394684-77cd-ee9f-d401-e730791bfb3e}">
+        <p14:section name="S3 · Nghiên cứu marketing là gì, để làm gì, có những loại nào" id="{62912c77-04fa-7eab-aef2-7afd93db2c0e}">
           <p14:sldIdLst>
             <p14:sldId id="266"/>
             <p14:sldId id="267"/>
@@ -203,7 +203,7 @@
             <p14:sldId id="289"/>
           </p14:sldIdLst>
         </p14:section>
-        <p14:section name="S5 · Tiến trình, đạo đức, hệ thống thông tin, người làm và người dùng" id="{1869110e-3d04-0eae-37f7-8f9d5cd96592}">
+        <p14:section name="S5 · Tiến trình, đạo đức, hệ thống thông tin, người làm và người dùng" id="{b2a88a0c-2689-70b3-d51e-95cae7a99162}">
           <p14:sldIdLst>
             <p14:sldId id="290"/>
             <p14:sldId id="291"/>
@@ -218,13 +218,13 @@
             <p14:sldId id="300"/>
           </p14:sldIdLst>
         </p14:section>
-        <p14:section name="S7 · Thực hành nhóm" id="{44ff38bd-c394-ccb7-71c7-0fe0071cef0d}">
+        <p14:section name="S7 · Thực hành nhóm" id="{bcd4739c-c5b1-43a1-4e59-2c26ea2884ed}">
           <p14:sldIdLst>
             <p14:sldId id="301"/>
             <p14:sldId id="302"/>
           </p14:sldIdLst>
         </p14:section>
-        <p14:section name="S8 · Kết buổi" id="{a4b856b7-dfe4-6711-5414-ca9de95c18e5}">
+        <p14:section name="S8 · Kết buổi" id="{9095471f-95a5-21c5-3de2-07b6e55f9908}">
           <p14:sldIdLst>
             <p14:sldId id="303"/>
             <p14:sldId id="304"/>
@@ -7949,11 +7949,11 @@
         <p:spPr>
           <a:xfrm>
             <a:off x="548640" y="1783080"/>
-            <a:ext cx="3505200" cy="3337560"/>
+            <a:ext cx="3505200" cy="3202940"/>
           </a:xfrm>
           <a:prstGeom prst="roundRect">
             <a:avLst>
-              <a:gd name="adj" fmla="val 4932"/>
+              <a:gd name="adj" fmla="val 5139"/>
             </a:avLst>
           </a:prstGeom>
           <a:solidFill>
@@ -8072,7 +8072,7 @@
         <p:spPr>
           <a:xfrm>
             <a:off x="685800" y="3042920"/>
-            <a:ext cx="3230880" cy="2032000"/>
+            <a:ext cx="3230880" cy="1897380"/>
           </a:xfrm>
           <a:prstGeom prst="rect">
             <a:avLst/>
@@ -8131,11 +8131,11 @@
         <p:spPr>
           <a:xfrm>
             <a:off x="4328160" y="1783080"/>
-            <a:ext cx="3505200" cy="3337560"/>
+            <a:ext cx="3505200" cy="3202940"/>
           </a:xfrm>
           <a:prstGeom prst="roundRect">
             <a:avLst>
-              <a:gd name="adj" fmla="val 4932"/>
+              <a:gd name="adj" fmla="val 5139"/>
             </a:avLst>
           </a:prstGeom>
           <a:solidFill>
@@ -8254,7 +8254,7 @@
         <p:spPr>
           <a:xfrm>
             <a:off x="4465320" y="2580640"/>
-            <a:ext cx="3230880" cy="2494280"/>
+            <a:ext cx="3230880" cy="2359660"/>
           </a:xfrm>
           <a:prstGeom prst="rect">
             <a:avLst/>
@@ -8323,18 +8323,18 @@
       </p:sp>
       <p:sp>
         <p:nvSpPr>
-          <p:cNvPr id="16" name="Thẻ Nguyễn &amp; Nguyễn (2015)"/>
+          <p:cNvPr id="16" name="Thẻ Nguyễn &amp; Nguyễn"/>
           <p:cNvSpPr/>
           <p:nvPr/>
         </p:nvSpPr>
         <p:spPr>
           <a:xfrm>
             <a:off x="8107680" y="1783080"/>
-            <a:ext cx="3505200" cy="3337560"/>
+            <a:ext cx="3505200" cy="3202940"/>
           </a:xfrm>
           <a:prstGeom prst="roundRect">
             <a:avLst>
-              <a:gd name="adj" fmla="val 4932"/>
+              <a:gd name="adj" fmla="val 5139"/>
             </a:avLst>
           </a:prstGeom>
           <a:solidFill>
@@ -8411,7 +8411,7 @@
         <p:spPr>
           <a:xfrm>
             <a:off x="8930640" y="1920240"/>
-            <a:ext cx="2499360" cy="1539240"/>
+            <a:ext cx="2499360" cy="1076960"/>
           </a:xfrm>
           <a:prstGeom prst="rect">
             <a:avLst/>
@@ -8438,7 +8438,7 @@
                 <a:ea typeface="Alexandria" pitchFamily="34" charset="-122"/>
                 <a:cs typeface="Alexandria" pitchFamily="34" charset="-120"/>
               </a:rPr>
-              <a:t>Nguyễn &amp; Nguyễn (2015)</a:t>
+              <a:t>Nguyễn &amp; Nguyễn</a:t>
             </a:r>
             <a:endParaRPr lang="en-US" sz="2800" dirty="0"/>
           </a:p>
@@ -8452,8 +8452,8 @@
         </p:nvSpPr>
         <p:spPr>
           <a:xfrm>
-            <a:off x="8244840" y="3505200"/>
-            <a:ext cx="3230880" cy="1569720"/>
+            <a:off x="8244840" y="3042920"/>
+            <a:ext cx="3230880" cy="1897380"/>
           </a:xfrm>
           <a:prstGeom prst="rect">
             <a:avLst/>
@@ -8472,7 +8472,7 @@
               <a:buNone/>
             </a:pPr>
             <a:r>
-              <a:rPr lang="en-US" sz="2600" b="1" dirty="0">
+              <a:rPr lang="en-US" sz="2600" dirty="0">
                 <a:solidFill>
                   <a:srgbClr val="2E2A3A"/>
                 </a:solidFill>
@@ -8480,7 +8480,7 @@
                 <a:ea typeface="Alexandria" pitchFamily="34" charset="-122"/>
                 <a:cs typeface="Alexandria" pitchFamily="34" charset="-120"/>
               </a:rPr>
-              <a:t>Chức năng</a:t>
+              <a:t>(2015) </a:t>
             </a:r>
             <a:pPr algn="l" indent="0" marL="0">
               <a:lnSpc>
@@ -8489,7 +8489,7 @@
               <a:buNone/>
             </a:pPr>
             <a:r>
-              <a:rPr lang="en-US" sz="2600" dirty="0">
+              <a:rPr lang="en-US" sz="2600" b="1" dirty="0">
                 <a:solidFill>
                   <a:srgbClr val="2E2A3A"/>
                 </a:solidFill>
@@ -8497,7 +8497,7 @@
                 <a:ea typeface="Alexandria" pitchFamily="34" charset="-122"/>
                 <a:cs typeface="Alexandria" pitchFamily="34" charset="-120"/>
               </a:rPr>
-              <a:t> gắn với </a:t>
+              <a:t>Chức năng</a:t>
             </a:r>
             <a:pPr algn="l" indent="0" marL="0">
               <a:lnSpc>
@@ -8506,6 +8506,23 @@
               <a:buNone/>
             </a:pPr>
             <a:r>
+              <a:rPr lang="en-US" sz="2600" dirty="0">
+                <a:solidFill>
+                  <a:srgbClr val="2E2A3A"/>
+                </a:solidFill>
+                <a:latin typeface="Alexandria" pitchFamily="34" charset="0"/>
+                <a:ea typeface="Alexandria" pitchFamily="34" charset="-122"/>
+                <a:cs typeface="Alexandria" pitchFamily="34" charset="-120"/>
+              </a:rPr>
+              <a:t> gắn với </a:t>
+            </a:r>
+            <a:pPr algn="l" indent="0" marL="0">
+              <a:lnSpc>
+                <a:spcPts val="3400"/>
+              </a:lnSpc>
+              <a:buNone/>
+            </a:pPr>
+            <a:r>
               <a:rPr lang="en-US" sz="2600" b="1" dirty="0">
                 <a:solidFill>
                   <a:srgbClr val="2E2A3A"/>
@@ -8528,7 +8545,7 @@
         </p:nvSpPr>
         <p:spPr>
           <a:xfrm>
-            <a:off x="548640" y="5394960"/>
+            <a:off x="548640" y="5351780"/>
             <a:ext cx="11064240" cy="685800"/>
           </a:xfrm>
           <a:prstGeom prst="roundRect">
@@ -8550,7 +8567,7 @@
         </p:nvSpPr>
         <p:spPr>
           <a:xfrm>
-            <a:off x="731520" y="5509260"/>
+            <a:off x="731520" y="5466080"/>
             <a:ext cx="457200" cy="457200"/>
           </a:xfrm>
           <a:prstGeom prst="ellipse">
@@ -8570,7 +8587,7 @@
         </p:nvSpPr>
         <p:spPr>
           <a:xfrm>
-            <a:off x="731520" y="5509260"/>
+            <a:off x="731520" y="5466080"/>
             <a:ext cx="457200" cy="457200"/>
           </a:xfrm>
           <a:prstGeom prst="rect">
@@ -8609,7 +8626,7 @@
         </p:nvSpPr>
         <p:spPr>
           <a:xfrm>
-            <a:off x="1325880" y="5394960"/>
+            <a:off x="1325880" y="5351780"/>
             <a:ext cx="10149840" cy="685800"/>
           </a:xfrm>
           <a:prstGeom prst="rect">
@@ -10193,7 +10210,7 @@
                 <a:ea typeface="Alexandria" pitchFamily="34" charset="-122"/>
                 <a:cs typeface="Alexandria" pitchFamily="34" charset="-120"/>
               </a:rPr>
-              <a:t>Không bảo đảm thành công</a:t>
+              <a:t>Không bảo đảm thành công</a:t>
             </a:r>
             <a:endParaRPr lang="en-US" sz="2600" dirty="0"/>
           </a:p>
@@ -11817,7 +11834,7 @@
                 <a:ea typeface="Alexandria" pitchFamily="34" charset="-122"/>
                 <a:cs typeface="Alexandria" pitchFamily="34" charset="-120"/>
               </a:rPr>
-              <a:t>Xác định hay giải quyết vấn đề? Hàn lâm hay ứng dụng?</a:t>
+              <a:t>Xác định hay giải quyết vấn đề? Hàn lâm hay ứng dụng?</a:t>
             </a:r>
             <a:endParaRPr lang="en-US" sz="2600" dirty="0"/>
           </a:p>
@@ -12147,7 +12164,7 @@
                 <a:ea typeface="Alexandria" pitchFamily="34" charset="-122"/>
                 <a:cs typeface="Alexandria" pitchFamily="34" charset="-120"/>
               </a:rPr>
-              <a:t>Định tính hay định lượng?</a:t>
+              <a:t>Định tính hay định lượng?</a:t>
             </a:r>
             <a:endParaRPr lang="en-US" sz="2600" dirty="0"/>
           </a:p>
@@ -17682,7 +17699,7 @@
                 <a:ea typeface="Alexandria" pitchFamily="34" charset="-122"/>
                 <a:cs typeface="Alexandria" pitchFamily="34" charset="-120"/>
               </a:rPr>
-              <a:t>Xem ảnh áo treo trên móc</a:t>
+              <a:t>Xem ảnh áo treo trên móc</a:t>
             </a:r>
             <a:endParaRPr lang="en-US" sz="2800" dirty="0"/>
           </a:p>
@@ -17892,7 +17909,7 @@
                 <a:ea typeface="Alexandria" pitchFamily="34" charset="-122"/>
                 <a:cs typeface="Alexandria" pitchFamily="34" charset="-120"/>
               </a:rPr>
-              <a:t>Xem ảnh người mẫu mặc</a:t>
+              <a:t>Xem ảnh người mẫu mặc</a:t>
             </a:r>
             <a:endParaRPr lang="en-US" sz="2800" dirty="0"/>
           </a:p>
@@ -23736,7 +23753,7 @@
                 <a:ea typeface="Alexandria" pitchFamily="34" charset="-122"/>
                 <a:cs typeface="Alexandria" pitchFamily="34" charset="-120"/>
               </a:rPr>
-              <a:t>Loại nào? Hàn lâm hay ứng dụng?</a:t>
+              <a:t>Loại nào? Hàn lâm hay ứng dụng?</a:t>
             </a:r>
             <a:endParaRPr lang="en-US" sz="3000" dirty="0"/>
           </a:p>
@@ -24164,7 +24181,7 @@
                 <a:ea typeface="Alexandria" pitchFamily="34" charset="-122"/>
                 <a:cs typeface="Alexandria" pitchFamily="34" charset="-120"/>
               </a:rPr>
-              <a:t>Loại nào? Định tính hay định lượng?</a:t>
+              <a:t>Loại nào? Định tính hay định lượng?</a:t>
             </a:r>
             <a:endParaRPr lang="en-US" sz="3000" dirty="0"/>
           </a:p>
@@ -27272,11 +27289,11 @@
         <p:spPr>
           <a:xfrm>
             <a:off x="502920" y="2697480"/>
-            <a:ext cx="1706880" cy="1802130"/>
+            <a:ext cx="1706880" cy="1488440"/>
           </a:xfrm>
           <a:prstGeom prst="roundRect">
             <a:avLst>
-              <a:gd name="adj" fmla="val 9643"/>
+              <a:gd name="adj" fmla="val 11058"/>
             </a:avLst>
           </a:prstGeom>
           <a:solidFill>
@@ -27353,7 +27370,7 @@
         <p:spPr>
           <a:xfrm>
             <a:off x="548640" y="2743200"/>
-            <a:ext cx="1615440" cy="1390650"/>
+            <a:ext cx="1615440" cy="1076960"/>
           </a:xfrm>
           <a:prstGeom prst="rect">
             <a:avLst/>
@@ -27367,12 +27384,12 @@
           <a:p>
             <a:pPr algn="l" indent="0" marL="0">
               <a:lnSpc>
-                <a:spcPts val="3300"/>
+                <a:spcPts val="3600"/>
               </a:lnSpc>
               <a:buNone/>
             </a:pPr>
             <a:r>
-              <a:rPr lang="en-US" sz="2500" b="1" dirty="0">
+              <a:rPr lang="en-US" sz="2800" b="1" dirty="0">
                 <a:solidFill>
                   <a:srgbClr val="2E2A3A"/>
                 </a:solidFill>
@@ -27382,7 +27399,7 @@
               </a:rPr>
               <a:t>Vấn đề</a:t>
             </a:r>
-            <a:endParaRPr lang="en-US" sz="2500" dirty="0"/>
+            <a:endParaRPr lang="en-US" sz="2800" dirty="0"/>
           </a:p>
         </p:txBody>
       </p:sp>
@@ -27395,11 +27412,11 @@
         <p:spPr>
           <a:xfrm>
             <a:off x="2392680" y="2697480"/>
-            <a:ext cx="1706880" cy="1802130"/>
+            <a:ext cx="1706880" cy="1488440"/>
           </a:xfrm>
           <a:prstGeom prst="roundRect">
             <a:avLst>
-              <a:gd name="adj" fmla="val 9643"/>
+              <a:gd name="adj" fmla="val 11058"/>
             </a:avLst>
           </a:prstGeom>
           <a:solidFill>
@@ -27476,7 +27493,7 @@
         <p:spPr>
           <a:xfrm>
             <a:off x="2438400" y="2743200"/>
-            <a:ext cx="1615440" cy="1390650"/>
+            <a:ext cx="1615440" cy="1076960"/>
           </a:xfrm>
           <a:prstGeom prst="rect">
             <a:avLst/>
@@ -27490,12 +27507,12 @@
           <a:p>
             <a:pPr algn="l" indent="0" marL="0">
               <a:lnSpc>
-                <a:spcPts val="3300"/>
+                <a:spcPts val="3600"/>
               </a:lnSpc>
               <a:buNone/>
             </a:pPr>
             <a:r>
-              <a:rPr lang="en-US" sz="2500" b="1" dirty="0">
+              <a:rPr lang="en-US" sz="2800" b="1" dirty="0">
                 <a:solidFill>
                   <a:srgbClr val="2E2A3A"/>
                 </a:solidFill>
@@ -27505,7 +27522,7 @@
               </a:rPr>
               <a:t>Mục tiêu</a:t>
             </a:r>
-            <a:endParaRPr lang="en-US" sz="2500" dirty="0"/>
+            <a:endParaRPr lang="en-US" sz="2800" dirty="0"/>
           </a:p>
         </p:txBody>
       </p:sp>
@@ -27518,11 +27535,11 @@
         <p:spPr>
           <a:xfrm>
             <a:off x="4282440" y="2697480"/>
-            <a:ext cx="1706880" cy="1802130"/>
+            <a:ext cx="1706880" cy="1488440"/>
           </a:xfrm>
           <a:prstGeom prst="roundRect">
             <a:avLst>
-              <a:gd name="adj" fmla="val 9643"/>
+              <a:gd name="adj" fmla="val 11058"/>
             </a:avLst>
           </a:prstGeom>
           <a:solidFill>
@@ -27599,7 +27616,7 @@
         <p:spPr>
           <a:xfrm>
             <a:off x="4328160" y="2743200"/>
-            <a:ext cx="1615440" cy="1390650"/>
+            <a:ext cx="1615440" cy="1076960"/>
           </a:xfrm>
           <a:prstGeom prst="rect">
             <a:avLst/>
@@ -27613,12 +27630,12 @@
           <a:p>
             <a:pPr algn="l" indent="0" marL="0">
               <a:lnSpc>
-                <a:spcPts val="3300"/>
+                <a:spcPts val="3600"/>
               </a:lnSpc>
               <a:buNone/>
             </a:pPr>
             <a:r>
-              <a:rPr lang="en-US" sz="2500" b="1" dirty="0">
+              <a:rPr lang="en-US" sz="2800" b="1" dirty="0">
                 <a:solidFill>
                   <a:srgbClr val="2E2A3A"/>
                 </a:solidFill>
@@ -27628,7 +27645,7 @@
               </a:rPr>
               <a:t>Mô hình</a:t>
             </a:r>
-            <a:endParaRPr lang="en-US" sz="2500" dirty="0"/>
+            <a:endParaRPr lang="en-US" sz="2800" dirty="0"/>
           </a:p>
         </p:txBody>
       </p:sp>
@@ -27641,11 +27658,11 @@
         <p:spPr>
           <a:xfrm>
             <a:off x="6172200" y="2697480"/>
-            <a:ext cx="1706880" cy="1802130"/>
+            <a:ext cx="1706880" cy="1488440"/>
           </a:xfrm>
           <a:prstGeom prst="roundRect">
             <a:avLst>
-              <a:gd name="adj" fmla="val 9643"/>
+              <a:gd name="adj" fmla="val 11058"/>
             </a:avLst>
           </a:prstGeom>
           <a:solidFill>
@@ -27722,7 +27739,7 @@
         <p:spPr>
           <a:xfrm>
             <a:off x="6217920" y="2743200"/>
-            <a:ext cx="1615440" cy="1390650"/>
+            <a:ext cx="1615440" cy="1076960"/>
           </a:xfrm>
           <a:prstGeom prst="rect">
             <a:avLst/>
@@ -27736,12 +27753,12 @@
           <a:p>
             <a:pPr algn="l" indent="0" marL="0">
               <a:lnSpc>
-                <a:spcPts val="3300"/>
+                <a:spcPts val="3600"/>
               </a:lnSpc>
               <a:buNone/>
             </a:pPr>
             <a:r>
-              <a:rPr lang="en-US" sz="2500" b="1" dirty="0">
+              <a:rPr lang="en-US" sz="2800" b="1" dirty="0">
                 <a:solidFill>
                   <a:srgbClr val="2E2A3A"/>
                 </a:solidFill>
@@ -27751,7 +27768,7 @@
               </a:rPr>
               <a:t>Thu thập</a:t>
             </a:r>
-            <a:endParaRPr lang="en-US" sz="2500" dirty="0"/>
+            <a:endParaRPr lang="en-US" sz="2800" dirty="0"/>
           </a:p>
         </p:txBody>
       </p:sp>
@@ -27764,11 +27781,11 @@
         <p:spPr>
           <a:xfrm>
             <a:off x="8061960" y="2697480"/>
-            <a:ext cx="1706880" cy="1802130"/>
+            <a:ext cx="1706880" cy="1488440"/>
           </a:xfrm>
           <a:prstGeom prst="roundRect">
             <a:avLst>
-              <a:gd name="adj" fmla="val 9643"/>
+              <a:gd name="adj" fmla="val 11058"/>
             </a:avLst>
           </a:prstGeom>
           <a:solidFill>
@@ -27845,7 +27862,7 @@
         <p:spPr>
           <a:xfrm>
             <a:off x="8107680" y="2743200"/>
-            <a:ext cx="1615440" cy="1390650"/>
+            <a:ext cx="1615440" cy="1076960"/>
           </a:xfrm>
           <a:prstGeom prst="rect">
             <a:avLst/>
@@ -27859,12 +27876,12 @@
           <a:p>
             <a:pPr algn="l" indent="0" marL="0">
               <a:lnSpc>
-                <a:spcPts val="3300"/>
+                <a:spcPts val="3600"/>
               </a:lnSpc>
               <a:buNone/>
             </a:pPr>
             <a:r>
-              <a:rPr lang="en-US" sz="2500" b="1" dirty="0">
+              <a:rPr lang="en-US" sz="2800" b="1" dirty="0">
                 <a:solidFill>
                   <a:srgbClr val="2E2A3A"/>
                 </a:solidFill>
@@ -27872,9 +27889,9 @@
                 <a:ea typeface="Alexandria" pitchFamily="34" charset="-122"/>
                 <a:cs typeface="Alexandria" pitchFamily="34" charset="-120"/>
               </a:rPr>
-              <a:t>Chuẩn bị &amp; phân tích</a:t>
-            </a:r>
-            <a:endParaRPr lang="en-US" sz="2500" dirty="0"/>
+              <a:t>Xử lý dữ liệu</a:t>
+            </a:r>
+            <a:endParaRPr lang="en-US" sz="2800" dirty="0"/>
           </a:p>
         </p:txBody>
       </p:sp>
@@ -27887,11 +27904,11 @@
         <p:spPr>
           <a:xfrm>
             <a:off x="9951720" y="2697480"/>
-            <a:ext cx="1706880" cy="1802130"/>
+            <a:ext cx="1706880" cy="1488440"/>
           </a:xfrm>
           <a:prstGeom prst="roundRect">
             <a:avLst>
-              <a:gd name="adj" fmla="val 9643"/>
+              <a:gd name="adj" fmla="val 11058"/>
             </a:avLst>
           </a:prstGeom>
           <a:solidFill>
@@ -27968,7 +27985,7 @@
         <p:spPr>
           <a:xfrm>
             <a:off x="9997440" y="2743200"/>
-            <a:ext cx="1615440" cy="1390650"/>
+            <a:ext cx="1615440" cy="1076960"/>
           </a:xfrm>
           <a:prstGeom prst="rect">
             <a:avLst/>
@@ -27982,12 +27999,12 @@
           <a:p>
             <a:pPr algn="l" indent="0" marL="0">
               <a:lnSpc>
-                <a:spcPts val="3300"/>
+                <a:spcPts val="3600"/>
               </a:lnSpc>
               <a:buNone/>
             </a:pPr>
             <a:r>
-              <a:rPr lang="en-US" sz="2500" b="1" dirty="0">
+              <a:rPr lang="en-US" sz="2800" b="1" dirty="0">
                 <a:solidFill>
                   <a:srgbClr val="2E2A3A"/>
                 </a:solidFill>
@@ -27997,7 +28014,7 @@
               </a:rPr>
               <a:t>Trình bày</a:t>
             </a:r>
-            <a:endParaRPr lang="en-US" sz="2500" dirty="0"/>
+            <a:endParaRPr lang="en-US" sz="2800" dirty="0"/>
           </a:p>
         </p:txBody>
       </p:sp>
@@ -28009,7 +28026,7 @@
         </p:nvSpPr>
         <p:spPr>
           <a:xfrm>
-            <a:off x="548640" y="4865370"/>
+            <a:off x="548640" y="4551680"/>
             <a:ext cx="11064240" cy="685800"/>
           </a:xfrm>
           <a:prstGeom prst="roundRect">
@@ -28031,7 +28048,7 @@
         </p:nvSpPr>
         <p:spPr>
           <a:xfrm>
-            <a:off x="731520" y="4979670"/>
+            <a:off x="731520" y="4665980"/>
             <a:ext cx="457200" cy="457200"/>
           </a:xfrm>
           <a:prstGeom prst="ellipse">
@@ -28051,7 +28068,7 @@
         </p:nvSpPr>
         <p:spPr>
           <a:xfrm>
-            <a:off x="731520" y="4979670"/>
+            <a:off x="731520" y="4665980"/>
             <a:ext cx="457200" cy="457200"/>
           </a:xfrm>
           <a:prstGeom prst="rect">
@@ -28090,7 +28107,7 @@
         </p:nvSpPr>
         <p:spPr>
           <a:xfrm>
-            <a:off x="1325880" y="4865370"/>
+            <a:off x="1325880" y="4551680"/>
             <a:ext cx="10149840" cy="685800"/>
           </a:xfrm>
           <a:prstGeom prst="rect">
@@ -28903,7 +28920,7 @@
                 <a:ea typeface="Alexandria" pitchFamily="34" charset="-122"/>
                 <a:cs typeface="Alexandria" pitchFamily="34" charset="-120"/>
               </a:rPr>
-              <a:t>Điều cần biết để quyết định</a:t>
+              <a:t>Điều cần biết để quyết định</a:t>
             </a:r>
             <a:endParaRPr lang="en-US" sz="2600" dirty="0"/>
           </a:p>
@@ -31486,7 +31503,7 @@
                 <a:ea typeface="Alexandria" pitchFamily="34" charset="-122"/>
                 <a:cs typeface="Alexandria" pitchFamily="34" charset="-120"/>
               </a:rPr>
-              <a:t>Chuẩn bị &amp; phân tích</a:t>
+              <a:t>Chuẩn bị &amp; phân tích</a:t>
             </a:r>
             <a:endParaRPr lang="en-US" sz="2800" dirty="0"/>
           </a:p>
@@ -31998,7 +32015,7 @@
       </p:sp>
       <p:sp>
         <p:nvSpPr>
-          <p:cNvPr id="6" name="Thẻ Sai đối tượng"/>
+          <p:cNvPr id="6" name="Thẻ Sai đối tượng"/>
           <p:cNvSpPr/>
           <p:nvPr/>
         </p:nvSpPr>
@@ -32113,7 +32130,7 @@
                 <a:ea typeface="Alexandria" pitchFamily="34" charset="-122"/>
                 <a:cs typeface="Alexandria" pitchFamily="34" charset="-120"/>
               </a:rPr>
-              <a:t>Sai đối tượng</a:t>
+              <a:t>Sai đối tượng</a:t>
             </a:r>
             <a:endParaRPr lang="en-US" sz="2800" dirty="0"/>
           </a:p>
@@ -32163,7 +32180,7 @@
       </p:sp>
       <p:sp>
         <p:nvSpPr>
-          <p:cNvPr id="11" name="Thẻ Không thiết kế"/>
+          <p:cNvPr id="11" name="Thẻ Không thiết kế"/>
           <p:cNvSpPr/>
           <p:nvPr/>
         </p:nvSpPr>
@@ -32278,7 +32295,7 @@
                 <a:ea typeface="Alexandria" pitchFamily="34" charset="-122"/>
                 <a:cs typeface="Alexandria" pitchFamily="34" charset="-120"/>
               </a:rPr>
-              <a:t>Không thiết kế</a:t>
+              <a:t>Không thiết kế</a:t>
             </a:r>
             <a:endParaRPr lang="en-US" sz="2800" dirty="0"/>
           </a:p>
@@ -32328,7 +32345,7 @@
       </p:sp>
       <p:sp>
         <p:nvSpPr>
-          <p:cNvPr id="16" name="Thẻ Theo cảm tính"/>
+          <p:cNvPr id="16" name="Thẻ Theo cảm tính"/>
           <p:cNvSpPr/>
           <p:nvPr/>
         </p:nvSpPr>
@@ -32443,7 +32460,7 @@
                 <a:ea typeface="Alexandria" pitchFamily="34" charset="-122"/>
                 <a:cs typeface="Alexandria" pitchFamily="34" charset="-120"/>
               </a:rPr>
-              <a:t>Theo cảm tính</a:t>
+              <a:t>Theo cảm tính</a:t>
             </a:r>
             <a:endParaRPr lang="en-US" sz="2800" dirty="0"/>
           </a:p>
@@ -37827,7 +37844,7 @@
                 <a:ea typeface="Alexandria" pitchFamily="34" charset="-122"/>
                 <a:cs typeface="Alexandria" pitchFamily="34" charset="-120"/>
               </a:rPr>
-              <a:t>Một điều hôm nay mình đã hiểu rõ</a:t>
+              <a:t>Một điều hôm nay mình đã hiểu rõ</a:t>
             </a:r>
             <a:endParaRPr lang="en-US" sz="2600" dirty="0"/>
           </a:p>
@@ -37992,7 +38009,7 @@
                 <a:ea typeface="Alexandria" pitchFamily="34" charset="-122"/>
                 <a:cs typeface="Alexandria" pitchFamily="34" charset="-120"/>
               </a:rPr>
-              <a:t>Một điều mình vẫn còn mơ hồ</a:t>
+              <a:t>Một điều mình vẫn còn mơ hồ</a:t>
             </a:r>
             <a:endParaRPr lang="en-US" sz="2600" dirty="0"/>
           </a:p>
@@ -39233,7 +39250,7 @@
                 <a:ea typeface="Alexandria" pitchFamily="34" charset="-122"/>
                 <a:cs typeface="Alexandria" pitchFamily="34" charset="-120"/>
               </a:rPr>
-              <a:t>Phiếu đăng ký đề tài sơ bộ · nhóm · 2,5% · nộp LMS trước Buổi 2 (hạn: …)</a:t>
+              <a:t>Phiếu đăng ký đề tài sơ bộ · nhóm · 2,5% · nộp LMS trước Buổi 2 (hạn: …)</a:t>
             </a:r>
             <a:endParaRPr lang="en-US" sz="2600" dirty="0"/>
           </a:p>
@@ -42811,7 +42828,7 @@
                 <a:ea typeface="Alexandria" pitchFamily="34" charset="-122"/>
                 <a:cs typeface="Alexandria" pitchFamily="34" charset="-120"/>
               </a:rPr>
-              <a:t>Bảng hỏi; giữa kỳ trước B11</a:t>
+              <a:t>Bảng hỏi; giữa kỳ</a:t>
             </a:r>
             <a:endParaRPr lang="en-US" sz="2600" dirty="0"/>
           </a:p>

</xml_diff>

<commit_message>
Finalize MKT1107 Buổi 1–10 decks; builder warns on unbreakable words, sizes table columns
530 slides, all text >= 24pt in Alexandria, speaker notes on every slide.

Co-Authored-By: Claude Opus 5.5 <noreply@anthropic.com>
Claude-Session: https://claude.ai/code/session_01Nw7HpGarY4JnDFYKKuarvZ
</commit_message>
<xml_diff>
--- a/mkt1107/output/MKT1107_W01_slides.pptx
+++ b/mkt1107/output/MKT1107_W01_slides.pptx
@@ -157,14 +157,14 @@
   <p:extLst>
     <p:ext uri="{521415D9-36F7-43E2-AB2F-B90AF26B5E84}">
       <p14:sectionLst xmlns:p14="http://schemas.microsoft.com/office/powerpoint/2010/main">
-        <p14:section name="Mở đầu" id="{213382eb-28df-c24e-356b-1dff0342f390}">
+        <p14:section name="Mở đầu" id="{7b9c0fb4-71ba-87a5-6e05-4896b5135fd1}">
           <p14:sldIdLst>
             <p14:sldId id="256"/>
             <p14:sldId id="257"/>
             <p14:sldId id="258"/>
           </p14:sldIdLst>
         </p14:section>
-        <p14:section name="S2 · Giới thiệu học phần" id="{18404e0f-82f9-4e98-2953-787fb0aa6402}">
+        <p14:section name="S2 · Giới thiệu học phần" id="{6cae8397-7d33-ab00-7ccd-2063a253d3e9}">
           <p14:sldIdLst>
             <p14:sldId id="259"/>
             <p14:sldId id="260"/>
@@ -175,7 +175,7 @@
             <p14:sldId id="265"/>
           </p14:sldIdLst>
         </p14:section>
-        <p14:section name="S3 · Nghiên cứu marketing là gì, để làm gì, có những loại nào" id="{62912c77-04fa-7eab-aef2-7afd93db2c0e}">
+        <p14:section name="S3 · Nghiên cứu marketing là gì, để làm gì, có những loại nào" id="{e82c7232-cdec-c8c8-0b9b-fc9178edfc9c}">
           <p14:sldIdLst>
             <p14:sldId id="266"/>
             <p14:sldId id="267"/>
@@ -203,7 +203,7 @@
             <p14:sldId id="289"/>
           </p14:sldIdLst>
         </p14:section>
-        <p14:section name="S5 · Tiến trình, đạo đức, hệ thống thông tin, người làm và người dùng" id="{b2a88a0c-2689-70b3-d51e-95cae7a99162}">
+        <p14:section name="S5 · Tiến trình, đạo đức, hệ thống thông tin, người làm và người dùng" id="{a8c486ab-bdeb-6959-5ba0-ad556cac8507}">
           <p14:sldIdLst>
             <p14:sldId id="290"/>
             <p14:sldId id="291"/>
@@ -218,13 +218,13 @@
             <p14:sldId id="300"/>
           </p14:sldIdLst>
         </p14:section>
-        <p14:section name="S7 · Thực hành nhóm" id="{bcd4739c-c5b1-43a1-4e59-2c26ea2884ed}">
+        <p14:section name="S7 · Thực hành nhóm" id="{98867e11-4c04-67ef-c984-f90c0a2aefc2}">
           <p14:sldIdLst>
             <p14:sldId id="301"/>
             <p14:sldId id="302"/>
           </p14:sldIdLst>
         </p14:section>
-        <p14:section name="S8 · Kết buổi" id="{9095471f-95a5-21c5-3de2-07b6e55f9908}">
+        <p14:section name="S8 · Kết buổi" id="{c6b27440-8874-9ea9-bcd8-2713315e217b}">
           <p14:sldIdLst>
             <p14:sldId id="303"/>
             <p14:sldId id="304"/>
@@ -18572,9 +18572,9 @@
             <a:tbl>
               <a:tblPr/>
               <a:tblGrid>
-                <a:gridCol w="2487163"/>
-                <a:gridCol w="4242571"/>
-                <a:gridCol w="4334505"/>
+                <a:gridCol w="2553830"/>
+                <a:gridCol w="4209596"/>
+                <a:gridCol w="4300815"/>
               </a:tblGrid>
               <a:tr h="524256">
                 <a:tc>
@@ -34627,9 +34627,9 @@
             <a:tbl>
               <a:tblPr/>
               <a:tblGrid>
-                <a:gridCol w="3287379"/>
-                <a:gridCol w="3644968"/>
-                <a:gridCol w="4131893"/>
+                <a:gridCol w="3344301"/>
+                <a:gridCol w="3618289"/>
+                <a:gridCol w="4101650"/>
               </a:tblGrid>
               <a:tr h="524256">
                 <a:tc>

</xml_diff>

<commit_message>
MKT1107: move lesson timings from slides into speaker notes
Section time ranges, activity stage minutes, '(45')' in titles, break
duration and 'N giây bàn với bạn' prompts now live in the notes as
'Thời gian: …'; activity stages show step numbers instead.

Co-Authored-By: Claude Opus 5.5 <noreply@anthropic.com>
Claude-Session: https://claude.ai/code/session_01Nw7HpGarY4JnDFYKKuarvZ
</commit_message>
<xml_diff>
--- a/mkt1107/output/MKT1107_W01_slides.pptx
+++ b/mkt1107/output/MKT1107_W01_slides.pptx
@@ -157,14 +157,14 @@
   <p:extLst>
     <p:ext uri="{521415D9-36F7-43E2-AB2F-B90AF26B5E84}">
       <p14:sectionLst xmlns:p14="http://schemas.microsoft.com/office/powerpoint/2010/main">
-        <p14:section name="Mở đầu" id="{7b9c0fb4-71ba-87a5-6e05-4896b5135fd1}">
+        <p14:section name="Mở đầu" id="{10c8945f-49f8-69eb-6162-52114e0c9c86}">
           <p14:sldIdLst>
             <p14:sldId id="256"/>
             <p14:sldId id="257"/>
             <p14:sldId id="258"/>
           </p14:sldIdLst>
         </p14:section>
-        <p14:section name="S2 · Giới thiệu học phần" id="{6cae8397-7d33-ab00-7ccd-2063a253d3e9}">
+        <p14:section name="S2 · Giới thiệu học phần" id="{9b9ae649-25e6-e32c-9f66-f27c1dfeb85c}">
           <p14:sldIdLst>
             <p14:sldId id="259"/>
             <p14:sldId id="260"/>
@@ -175,7 +175,7 @@
             <p14:sldId id="265"/>
           </p14:sldIdLst>
         </p14:section>
-        <p14:section name="S3 · Nghiên cứu marketing là gì, để làm gì, có những loại nào" id="{e82c7232-cdec-c8c8-0b9b-fc9178edfc9c}">
+        <p14:section name="S3 · Nghiên cứu marketing là gì, để làm gì, có những loại nào" id="{9bb77e60-7f85-65fa-66b7-a72eaeb9223f}">
           <p14:sldIdLst>
             <p14:sldId id="266"/>
             <p14:sldId id="267"/>
@@ -203,7 +203,7 @@
             <p14:sldId id="289"/>
           </p14:sldIdLst>
         </p14:section>
-        <p14:section name="S5 · Tiến trình, đạo đức, hệ thống thông tin, người làm và người dùng" id="{a8c486ab-bdeb-6959-5ba0-ad556cac8507}">
+        <p14:section name="S5 · Tiến trình, đạo đức, hệ thống thông tin, người làm và người dùng" id="{6fbf0474-b9f6-97bf-5156-838c4d35dd53}">
           <p14:sldIdLst>
             <p14:sldId id="290"/>
             <p14:sldId id="291"/>
@@ -218,13 +218,13 @@
             <p14:sldId id="300"/>
           </p14:sldIdLst>
         </p14:section>
-        <p14:section name="S7 · Thực hành nhóm" id="{98867e11-4c04-67ef-c984-f90c0a2aefc2}">
+        <p14:section name="S7 · Thực hành nhóm" id="{033aa834-dce0-0213-f986-29b6cfef7cac}">
           <p14:sldIdLst>
             <p14:sldId id="301"/>
             <p14:sldId id="302"/>
           </p14:sldIdLst>
         </p14:section>
-        <p14:section name="S8 · Kết buổi" id="{c6b27440-8874-9ea9-bcd8-2713315e217b}">
+        <p14:section name="S8 · Kết buổi" id="{100ac52a-0528-4a4c-eb35-6c2d431f4fa4}">
           <p14:sldIdLst>
             <p14:sldId id="303"/>
             <p14:sldId id="304"/>
@@ -818,7 +818,8 @@
           <a:p>
             <a:r>
               <a:rPr lang="en-US" dirty="0"/>
-              <a:t>Phân đoạn dày nhất buổi — 25 phút (phút 15–40): định nghĩa, bốn thành tố, vai trò và giới hạn, mục đích và phạm vi, rồi phân loại theo ba tiêu chí.
+              <a:t>Thời gian: phút 15–40 của buổi học.
+Phân đoạn dày nhất buổi — 25 phút (phút 15–40): định nghĩa, bốn thành tố, vai trò và giới hạn, mục đích và phạm vi, rồi phân loại theo ba tiêu chí.
 Phần quan trọng nhất là tiêu chí 2 (khám phá, mô tả, tương quan, nhân quả) — đi chậm ở đó, vì ngay sau phần này lớp sẽ làm hoạt động Phân loại nhanh.
 Lưu ý cho giảng viên: nếu chậm giờ, phần mục đích và phạm vi chỉ nêu tên 6 phạm vi; phần so sánh nghiên cứu marketing với nghiên cứu thị trường chuyển sang tài liệu đọc thêm.</a:t>
             </a:r>
@@ -2288,7 +2289,8 @@
           <a:p>
             <a:r>
               <a:rPr lang="en-US" dirty="0"/>
-              <a:t>Hoạt động S4 (phút 40–48), làm theo cặp với bạn ngồi cạnh, không nộp, không chấm điểm.
+              <a:t>Thời gian: mỗi tình huống 30 giây bàn với bạn rồi giơ tay.
+Hoạt động S4 (phút 40–48), làm theo cặp với bạn ngồi cạnh, không nộp, không chấm điểm.
 Đọc kịch bản mở đầu: “Bây giờ mình thử dùng ngay ba tiêu chí vừa học. Tôi sẽ đọc 6 tình huống. Mỗi tình huống, các bạn có 30 giây bàn với bạn bên cạnh, rồi khi tôi đếm 3–2–1 thì giơ tay: 1 ngón là khám phá, 2 ngón là mô tả, 3 ngón là tương quan, 4 ngón là nhân quả. Cả lớp giơ cùng lúc, không nhìn bạn khác. Bắt đầu nhé.”
 Mỗi tình huống khoảng 45 giây: đọc → 30 giây thảo luận → 3–2–1 giơ tay → nhìn lớp, nói đáp án trong một câu. Với một số tình huống, hỏi thêm: định tính hay định lượng? hàn lâm hay ứng dụng?
 Nếu ít bạn giơ tay: nhắc “sai cũng không sao — đây là luyện tập”, giảng viên giơ tay làm mẫu. Ai không muốn giơ tay có thể ghi đáp án ra giấy.
@@ -3116,7 +3118,8 @@
           <a:p>
             <a:r>
               <a:rPr lang="en-US" dirty="0"/>
-              <a:t>Giải lao 15 phút (phút 48–63). Điền giờ quay lại lên slide hoặc nói to trước khi lớp ra ngoài.
+              <a:t>Thời gian: giải lao 15 phút.
+Giải lao 15 phút (phút 48–63). Điền giờ quay lại lên slide hoặc nói to trước khi lớp ra ngoài.
 Trong giờ giải lao: vẽ sẵn 6 ô trống lên bảng cho phần tiến trình 6 bước — sau giải lao sẽ điền dần theo ví dụ chuỗi trà sữa.
 Nếu có sinh viên hỏi riêng về cách đánh giá hoặc hạn nộp M1, trả lời theo lịch trên LMS.
 Lưu ý cho giảng viên: giờ quay lại trên slide đang để “…” — điền trước buổi học.</a:t>
@@ -3207,7 +3210,8 @@
           <a:p>
             <a:r>
               <a:rPr lang="en-US" dirty="0"/>
-              <a:t>Phân đoạn S5, khoảng 27 phút (phút 63–90). Bốn phần: tiến trình 6 bước với một ví dụ chạy xuyên suốt (khoảng 13 phút); đặc điểm và đạo đức của hoạt động nghiên cứu (khoảng 4 phút); hệ thống thông tin marketing (khoảng 6 phút); ai làm, ai dùng nghiên cứu (khoảng 4 phút).
+              <a:t>Thời gian: phút 63–90 của buổi học.
+Phân đoạn S5, khoảng 27 phút (phút 63–90). Bốn phần: tiến trình 6 bước với một ví dụ chạy xuyên suốt (khoảng 13 phút); đặc điểm và đạo đức của hoạt động nghiên cứu (khoảng 4 phút); hệ thống thông tin marketing (khoảng 6 phút); ai làm, ai dùng nghiên cứu (khoảng 4 phút).
 Chào lớp trở lại, kiểm tra nhanh mọi người đã vào chỗ.
 Lưu ý cho giảng viên: nếu trễ giờ, rút phần người thực hiện và người sử dụng còn 2 phút với một slide tóm tắt; không cắt phần thực hành S7 và phần kết buổi S8.</a:t>
             </a:r>
@@ -3663,7 +3667,8 @@
           <a:p>
             <a:r>
               <a:rPr lang="en-US" dirty="0"/>
-              <a:t>Chuyển sang phần giới thiệu học phần, khoảng 10 phút (phút 5–15). Phần này nói nhanh, gọn: mục tiêu, cách học bằng dự án nhóm, lộ trình, cách đánh giá và hai quy ước dùng suốt học phần (dùng AI và trích dẫn APA 7).
+              <a:t>Thời gian: phút 5–15 của buổi học.
+Chuyển sang phần giới thiệu học phần, khoảng 10 phút (phút 5–15). Phần này nói nhanh, gọn: mục tiêu, cách học bằng dự án nhóm, lộ trình, cách đánh giá và hai quy ước dùng suốt học phần (dùng AI và trích dẫn APA 7).
 Nhắc sinh viên rằng mọi chi tiết đều có trong đề cương trên LMS — trên lớp chỉ nêu những điều cần nhớ nhất. Không đọc nguyên văn chuẩn đầu ra hay bảng đánh giá trong đề cương.
 Nếu lớp vào muộn hoặc phần khởi động kéo dài, có thể rút phần này còn 7–8 phút bằng cách nói nhanh slide mục tiêu và slide quy ước AI.</a:t>
             </a:r>
@@ -4302,7 +4307,8 @@
           <a:p>
             <a:r>
               <a:rPr lang="en-US" dirty="0"/>
-              <a:t>Phân đoạn S7 — thực hành nhóm 45 phút (phút 94–139), hoạt động Xưởng đề tài. Đây là phần không được cắt kể cả khi trễ giờ.
+              <a:t>Thời gian: phút 94–139 của buổi học.
+Phân đoạn S7 — thực hành nhóm 45 phút (phút 94–139), hoạt động Xưởng đề tài. Đây là phần không được cắt kể cả khi trễ giờ.
 Trước khi chiếu slide nhiệm vụ, nhắc sinh viên mở máy tính và chuẩn bị phiếu nhóm.
 Lưu ý cho giảng viên: kịch bản, phiếu nhóm và cách phản hồi nằm trong phiếu hoạt động Xưởng đề tài; nhớ mang danh sách 10 lĩnh vực gợi ý phòng khi nhóm bí đề tài.
 Khi các nhóm bắt đầu, đi một vòng nhanh để chắc chắn mọi sinh viên đã có nhóm; ai còn lẻ thì ghép ngay trong 3 phút đầu và ghi danh sách nhóm.</a:t>
@@ -4393,7 +4399,9 @@
           <a:p>
             <a:r>
               <a:rPr lang="en-US" dirty="0"/>
-              <a:t>Để slide này trên màn hình suốt 45 phút. Kịch bản mở đầu: “45 phút tới là thời gian của nhóm. Ai chưa có nhóm thì có 3 phút để tìm nhóm 2–3 người — ai còn lẻ thì giơ tay, tôi ghép. Lưu ý quan trọng nhất: chọn lĩnh vực mà các bạn hỏi được người thật, vì cuối kỳ các bạn phải thu dữ liệu. Tôi sẽ đi từng nhóm.”
+              <a:t>Thời gian: 45 phút.
+Phân bổ thời gian — chặng 1: 10 phút; chặng 2: 10 phút; chặng 3: 15 phút; chặng 4: 10 phút; (chặng 4 gốc: “4–5 nhóm chia sẻ, mỗi nhóm 1 phút”).
+Để slide này trên màn hình suốt 45 phút. Kịch bản mở đầu: “45 phút tới là thời gian của nhóm. Ai chưa có nhóm thì có 3 phút để tìm nhóm 2–3 người — ai còn lẻ thì giơ tay, tôi ghép. Lưu ý quan trọng nhất: chọn lĩnh vực mà các bạn hỏi được người thật, vì cuối kỳ các bạn phải thu dữ liệu. Tôi sẽ đi từng nhóm.”
 Chặng 1: chọn một lĩnh vực hoặc thương hiệu nhóm hiểu và tiếp cận được người trả lời, ghi một hiện tượng tích cực (cơ hội) hoặc tiêu cực (vấn đề). Chặng 2: đặt mình vào vị trí giám đốc marketing, viết 3 quyết định — ví dụ “Có nên mở thêm cửa hàng gần khu ký túc xá không?”. Chặng 3: viết lại thành điều cần biết, bắt đầu bằng “Xác định…”, “Đo lường…”, “Tìm hiểu…”, “So sánh…”; ghi ai sẽ trả lời.
 Khi đi các bàn: nếu câu hỏi là chủ đề, hỏi lại “Giám đốc sẽ làm gì khác đi sau khi biết điều này?”; nếu quá rộng, thu hẹp một sản phẩm, một nhóm khách, một khu vực; nếu đối tượng khó tiếp cận, khuyên đổi ngay.
 Câu chốt khi chia sẻ: “Một vấn đề nghiên cứu tốt trả lời được câu hỏi: giám đốc sẽ dùng kết quả này để quyết định điều gì?”</a:t>
@@ -4484,7 +4492,8 @@
           <a:p>
             <a:r>
               <a:rPr lang="en-US" dirty="0"/>
-              <a:t>Phân đoạn S8 — kết buổi, khoảng 7 phút (phút 139–146), còn 4 phút dự phòng đến hết buổi.
+              <a:t>Thời gian: phút 139–146 của buổi học.
+Phân đoạn S8 — kết buổi, khoảng 7 phút (phút 139–146), còn 4 phút dự phòng đến hết buổi.
 Yêu cầu các nhóm dừng làm, chụp hoặc lưu phiếu nhóm để hoàn thiện thành M1 ở nhà.
 Phát phiếu ra về (giấy nhỏ hoặc trang cuối phiếu hoạt động). Phần này không được cắt kể cả khi trễ giờ — phiếu ra về là cách giảng viên biết lớp đã hiểu đến đâu.</a:t>
             </a:r>
@@ -5353,8 +5362,8 @@
         </p:nvSpPr>
         <p:spPr>
           <a:xfrm>
-            <a:off x="3840480" y="2103120"/>
-            <a:ext cx="6766560" cy="2194560"/>
+            <a:off x="3840480" y="2240280"/>
+            <a:ext cx="6766560" cy="2377440"/>
           </a:xfrm>
           <a:prstGeom prst="rect">
             <a:avLst/>
@@ -7346,49 +7355,7 @@
       </p:sp>
       <p:sp>
         <p:nvSpPr>
-          <p:cNvPr id="8" name="Text 6"/>
-          <p:cNvSpPr txBox="1"/>
-          <p:nvPr/>
-        </p:nvSpPr>
-        <p:spPr>
-          <a:xfrm>
-            <a:off x="3840480" y="1417320"/>
-            <a:ext cx="6766560" cy="594360"/>
-          </a:xfrm>
-          <a:prstGeom prst="rect">
-            <a:avLst/>
-          </a:prstGeom>
-          <a:noFill/>
-          <a:ln/>
-        </p:spPr>
-        <p:txBody>
-          <a:bodyPr wrap="square" lIns="76200" tIns="76200" rIns="76200" bIns="76200" rtlCol="0" anchor="t"/>
-          <a:lstStyle/>
-          <a:p>
-            <a:pPr algn="l" indent="0" marL="0">
-              <a:lnSpc>
-                <a:spcPts val="3600"/>
-              </a:lnSpc>
-              <a:buNone/>
-            </a:pPr>
-            <a:r>
-              <a:rPr lang="en-US" sz="2800" b="1" dirty="0">
-                <a:solidFill>
-                  <a:srgbClr val="962B7C"/>
-                </a:solidFill>
-                <a:latin typeface="Alexandria" pitchFamily="34" charset="0"/>
-                <a:ea typeface="Alexandria" pitchFamily="34" charset="-122"/>
-                <a:cs typeface="Alexandria" pitchFamily="34" charset="-120"/>
-              </a:rPr>
-              <a:t>15–40 phút</a:t>
-            </a:r>
-            <a:endParaRPr lang="en-US" sz="2800" dirty="0"/>
-          </a:p>
-        </p:txBody>
-      </p:sp>
-      <p:sp>
-        <p:nvSpPr>
-          <p:cNvPr id="9" name="Text 0"/>
+          <p:cNvPr id="8" name="Text 0"/>
           <p:cNvSpPr/>
           <p:nvPr>
             <p:ph idx="100" type="title" hasCustomPrompt="1"/>
@@ -7396,17 +7363,17 @@
         </p:nvSpPr>
         <p:spPr>
           <a:xfrm>
-            <a:off x="3840480" y="2103120"/>
-            <a:ext cx="6766560" cy="2194560"/>
-          </a:xfrm>
-          <a:prstGeom prst="rect">
-            <a:avLst/>
-          </a:prstGeom>
-          <a:noFill/>
-          <a:ln/>
-        </p:spPr>
-        <p:txBody>
-          <a:bodyPr wrap="square" lIns="76200" tIns="76200" rIns="76200" bIns="76200" rtlCol="0" anchor="t"/>
+            <a:off x="3840480" y="2240280"/>
+            <a:ext cx="6766560" cy="2377440"/>
+          </a:xfrm>
+          <a:prstGeom prst="rect">
+            <a:avLst/>
+          </a:prstGeom>
+          <a:noFill/>
+          <a:ln/>
+        </p:spPr>
+        <p:txBody>
+          <a:bodyPr wrap="square" lIns="76200" tIns="76200" rIns="76200" bIns="76200" rtlCol="0" anchor="ctr"/>
           <a:lstStyle/>
           <a:p>
             <a:pPr algn="l" indent="0" marL="0">
@@ -20030,7 +19997,7 @@
               <a:buNone/>
             </a:pPr>
             <a:r>
-              <a:rPr lang="en-US" sz="3400" b="1" dirty="0">
+              <a:rPr lang="en-US" sz="3600" b="1" dirty="0">
                 <a:solidFill>
                   <a:srgbClr val="2E2A3A"/>
                 </a:solidFill>
@@ -20038,9 +20005,9 @@
                 <a:ea typeface="Alexandria" pitchFamily="34" charset="-122"/>
                 <a:cs typeface="Alexandria" pitchFamily="34" charset="-120"/>
               </a:rPr>
-              <a:t>Phân loại nhanh: 30 giây bàn với bạn, rồi giơ tay</a:t>
-            </a:r>
-            <a:endParaRPr lang="en-US" sz="3400" dirty="0"/>
+              <a:t>Phân loại nhanh: bàn với bạn, rồi giơ tay</a:t>
+            </a:r>
+            <a:endParaRPr lang="en-US" sz="3600" dirty="0"/>
           </a:p>
         </p:txBody>
       </p:sp>
@@ -26601,7 +26568,7 @@
                 <a:ea typeface="Alexandria" pitchFamily="34" charset="-122"/>
                 <a:cs typeface="Alexandria" pitchFamily="34" charset="-120"/>
               </a:rPr>
-              <a:t>15'</a:t>
+              <a:t>Nghỉ</a:t>
             </a:r>
             <a:endParaRPr lang="en-US" sz="9600" dirty="0"/>
           </a:p>
@@ -26643,7 +26610,7 @@
                 <a:ea typeface="Alexandria" pitchFamily="34" charset="-122"/>
                 <a:cs typeface="Alexandria" pitchFamily="34" charset="-120"/>
               </a:rPr>
-              <a:t>Giải lao 15 phút</a:t>
+              <a:t>Giải lao</a:t>
             </a:r>
             <a:endParaRPr lang="en-US" sz="4800" dirty="0"/>
           </a:p>
@@ -26905,49 +26872,7 @@
       </p:sp>
       <p:sp>
         <p:nvSpPr>
-          <p:cNvPr id="8" name="Text 6"/>
-          <p:cNvSpPr txBox="1"/>
-          <p:nvPr/>
-        </p:nvSpPr>
-        <p:spPr>
-          <a:xfrm>
-            <a:off x="3840480" y="1417320"/>
-            <a:ext cx="6766560" cy="594360"/>
-          </a:xfrm>
-          <a:prstGeom prst="rect">
-            <a:avLst/>
-          </a:prstGeom>
-          <a:noFill/>
-          <a:ln/>
-        </p:spPr>
-        <p:txBody>
-          <a:bodyPr wrap="square" lIns="76200" tIns="76200" rIns="76200" bIns="76200" rtlCol="0" anchor="t"/>
-          <a:lstStyle/>
-          <a:p>
-            <a:pPr algn="l" indent="0" marL="0">
-              <a:lnSpc>
-                <a:spcPts val="3600"/>
-              </a:lnSpc>
-              <a:buNone/>
-            </a:pPr>
-            <a:r>
-              <a:rPr lang="en-US" sz="2800" b="1" dirty="0">
-                <a:solidFill>
-                  <a:srgbClr val="962B7C"/>
-                </a:solidFill>
-                <a:latin typeface="Alexandria" pitchFamily="34" charset="0"/>
-                <a:ea typeface="Alexandria" pitchFamily="34" charset="-122"/>
-                <a:cs typeface="Alexandria" pitchFamily="34" charset="-120"/>
-              </a:rPr>
-              <a:t>63–90 phút</a:t>
-            </a:r>
-            <a:endParaRPr lang="en-US" sz="2800" dirty="0"/>
-          </a:p>
-        </p:txBody>
-      </p:sp>
-      <p:sp>
-        <p:nvSpPr>
-          <p:cNvPr id="9" name="Text 0"/>
+          <p:cNvPr id="8" name="Text 0"/>
           <p:cNvSpPr/>
           <p:nvPr>
             <p:ph idx="100" type="title" hasCustomPrompt="1"/>
@@ -26955,17 +26880,17 @@
         </p:nvSpPr>
         <p:spPr>
           <a:xfrm>
-            <a:off x="3840480" y="2103120"/>
-            <a:ext cx="6766560" cy="2194560"/>
-          </a:xfrm>
-          <a:prstGeom prst="rect">
-            <a:avLst/>
-          </a:prstGeom>
-          <a:noFill/>
-          <a:ln/>
-        </p:spPr>
-        <p:txBody>
-          <a:bodyPr wrap="square" lIns="76200" tIns="76200" rIns="76200" bIns="76200" rtlCol="0" anchor="t"/>
+            <a:off x="3840480" y="2240280"/>
+            <a:ext cx="6766560" cy="2377440"/>
+          </a:xfrm>
+          <a:prstGeom prst="rect">
+            <a:avLst/>
+          </a:prstGeom>
+          <a:noFill/>
+          <a:ln/>
+        </p:spPr>
+        <p:txBody>
+          <a:bodyPr wrap="square" lIns="76200" tIns="76200" rIns="76200" bIns="76200" rtlCol="0" anchor="ctr"/>
           <a:lstStyle/>
           <a:p>
             <a:pPr algn="l" indent="0" marL="0">
@@ -30918,49 +30843,7 @@
       </p:sp>
       <p:sp>
         <p:nvSpPr>
-          <p:cNvPr id="8" name="Text 6"/>
-          <p:cNvSpPr txBox="1"/>
-          <p:nvPr/>
-        </p:nvSpPr>
-        <p:spPr>
-          <a:xfrm>
-            <a:off x="3840480" y="1417320"/>
-            <a:ext cx="6766560" cy="594360"/>
-          </a:xfrm>
-          <a:prstGeom prst="rect">
-            <a:avLst/>
-          </a:prstGeom>
-          <a:noFill/>
-          <a:ln/>
-        </p:spPr>
-        <p:txBody>
-          <a:bodyPr wrap="square" lIns="76200" tIns="76200" rIns="76200" bIns="76200" rtlCol="0" anchor="t"/>
-          <a:lstStyle/>
-          <a:p>
-            <a:pPr algn="l" indent="0" marL="0">
-              <a:lnSpc>
-                <a:spcPts val="3600"/>
-              </a:lnSpc>
-              <a:buNone/>
-            </a:pPr>
-            <a:r>
-              <a:rPr lang="en-US" sz="2800" b="1" dirty="0">
-                <a:solidFill>
-                  <a:srgbClr val="962B7C"/>
-                </a:solidFill>
-                <a:latin typeface="Alexandria" pitchFamily="34" charset="0"/>
-                <a:ea typeface="Alexandria" pitchFamily="34" charset="-122"/>
-                <a:cs typeface="Alexandria" pitchFamily="34" charset="-120"/>
-              </a:rPr>
-              <a:t>5–15 phút</a:t>
-            </a:r>
-            <a:endParaRPr lang="en-US" sz="2800" dirty="0"/>
-          </a:p>
-        </p:txBody>
-      </p:sp>
-      <p:sp>
-        <p:nvSpPr>
-          <p:cNvPr id="9" name="Text 0"/>
+          <p:cNvPr id="8" name="Text 0"/>
           <p:cNvSpPr/>
           <p:nvPr>
             <p:ph idx="100" type="title" hasCustomPrompt="1"/>
@@ -30968,17 +30851,17 @@
         </p:nvSpPr>
         <p:spPr>
           <a:xfrm>
-            <a:off x="3840480" y="2103120"/>
-            <a:ext cx="6766560" cy="2194560"/>
-          </a:xfrm>
-          <a:prstGeom prst="rect">
-            <a:avLst/>
-          </a:prstGeom>
-          <a:noFill/>
-          <a:ln/>
-        </p:spPr>
-        <p:txBody>
-          <a:bodyPr wrap="square" lIns="76200" tIns="76200" rIns="76200" bIns="76200" rtlCol="0" anchor="t"/>
+            <a:off x="3840480" y="2240280"/>
+            <a:ext cx="6766560" cy="2377440"/>
+          </a:xfrm>
+          <a:prstGeom prst="rect">
+            <a:avLst/>
+          </a:prstGeom>
+          <a:noFill/>
+          <a:ln/>
+        </p:spPr>
+        <p:txBody>
+          <a:bodyPr wrap="square" lIns="76200" tIns="76200" rIns="76200" bIns="76200" rtlCol="0" anchor="ctr"/>
           <a:lstStyle/>
           <a:p>
             <a:pPr algn="l" indent="0" marL="0">
@@ -36309,49 +36192,7 @@
       </p:sp>
       <p:sp>
         <p:nvSpPr>
-          <p:cNvPr id="8" name="Text 6"/>
-          <p:cNvSpPr txBox="1"/>
-          <p:nvPr/>
-        </p:nvSpPr>
-        <p:spPr>
-          <a:xfrm>
-            <a:off x="3840480" y="1417320"/>
-            <a:ext cx="6766560" cy="594360"/>
-          </a:xfrm>
-          <a:prstGeom prst="rect">
-            <a:avLst/>
-          </a:prstGeom>
-          <a:noFill/>
-          <a:ln/>
-        </p:spPr>
-        <p:txBody>
-          <a:bodyPr wrap="square" lIns="76200" tIns="76200" rIns="76200" bIns="76200" rtlCol="0" anchor="t"/>
-          <a:lstStyle/>
-          <a:p>
-            <a:pPr algn="l" indent="0" marL="0">
-              <a:lnSpc>
-                <a:spcPts val="3600"/>
-              </a:lnSpc>
-              <a:buNone/>
-            </a:pPr>
-            <a:r>
-              <a:rPr lang="en-US" sz="2800" b="1" dirty="0">
-                <a:solidFill>
-                  <a:srgbClr val="962B7C"/>
-                </a:solidFill>
-                <a:latin typeface="Alexandria" pitchFamily="34" charset="0"/>
-                <a:ea typeface="Alexandria" pitchFamily="34" charset="-122"/>
-                <a:cs typeface="Alexandria" pitchFamily="34" charset="-120"/>
-              </a:rPr>
-              <a:t>94–139 phút</a:t>
-            </a:r>
-            <a:endParaRPr lang="en-US" sz="2800" dirty="0"/>
-          </a:p>
-        </p:txBody>
-      </p:sp>
-      <p:sp>
-        <p:nvSpPr>
-          <p:cNvPr id="9" name="Text 0"/>
+          <p:cNvPr id="8" name="Text 0"/>
           <p:cNvSpPr/>
           <p:nvPr>
             <p:ph idx="100" type="title" hasCustomPrompt="1"/>
@@ -36359,17 +36200,17 @@
         </p:nvSpPr>
         <p:spPr>
           <a:xfrm>
-            <a:off x="3840480" y="2103120"/>
-            <a:ext cx="6766560" cy="2194560"/>
-          </a:xfrm>
-          <a:prstGeom prst="rect">
-            <a:avLst/>
-          </a:prstGeom>
-          <a:noFill/>
-          <a:ln/>
-        </p:spPr>
-        <p:txBody>
-          <a:bodyPr wrap="square" lIns="76200" tIns="76200" rIns="76200" bIns="76200" rtlCol="0" anchor="t"/>
+            <a:off x="3840480" y="2240280"/>
+            <a:ext cx="6766560" cy="2377440"/>
+          </a:xfrm>
+          <a:prstGeom prst="rect">
+            <a:avLst/>
+          </a:prstGeom>
+          <a:noFill/>
+          <a:ln/>
+        </p:spPr>
+        <p:txBody>
+          <a:bodyPr wrap="square" lIns="76200" tIns="76200" rIns="76200" bIns="76200" rtlCol="0" anchor="ctr"/>
           <a:lstStyle/>
           <a:p>
             <a:pPr algn="l" indent="0" marL="0">
@@ -36558,7 +36399,7 @@
                 <a:ea typeface="Alexandria" pitchFamily="34" charset="-122"/>
                 <a:cs typeface="Alexandria" pitchFamily="34" charset="-120"/>
               </a:rPr>
-              <a:t>Xưởng đề tài (45'): từ quyết định kinh doanh đến vấn đề nghiên cứu</a:t>
+              <a:t>Xưởng đề tài: từ quyết định kinh doanh đến vấn đề nghiên cứu</a:t>
             </a:r>
             <a:endParaRPr lang="en-US" sz="3400" dirty="0"/>
           </a:p>
@@ -36595,7 +36436,7 @@
         <p:spPr>
           <a:xfrm>
             <a:off x="640080" y="1828800"/>
-            <a:ext cx="1280160" cy="548640"/>
+            <a:ext cx="731520" cy="548640"/>
           </a:xfrm>
           <a:prstGeom prst="roundRect">
             <a:avLst>
@@ -36617,7 +36458,7 @@
         <p:spPr>
           <a:xfrm>
             <a:off x="640080" y="1828800"/>
-            <a:ext cx="1280160" cy="548640"/>
+            <a:ext cx="731520" cy="548640"/>
           </a:xfrm>
           <a:prstGeom prst="rect">
             <a:avLst/>
@@ -36644,7 +36485,7 @@
                 <a:ea typeface="Alexandria" pitchFamily="34" charset="-122"/>
                 <a:cs typeface="Alexandria" pitchFamily="34" charset="-120"/>
               </a:rPr>
-              <a:t>10'</a:t>
+              <a:t>1</a:t>
             </a:r>
             <a:endParaRPr lang="en-US" sz="2400" dirty="0"/>
           </a:p>
@@ -36658,8 +36499,8 @@
         </p:nvSpPr>
         <p:spPr>
           <a:xfrm>
-            <a:off x="2103120" y="1783080"/>
-            <a:ext cx="9372600" cy="640080"/>
+            <a:off x="1554480" y="1783080"/>
+            <a:ext cx="9921240" cy="640080"/>
           </a:xfrm>
           <a:prstGeom prst="rect">
             <a:avLst/>
@@ -36723,7 +36564,7 @@
         <p:spPr>
           <a:xfrm>
             <a:off x="640080" y="2606040"/>
-            <a:ext cx="1280160" cy="548640"/>
+            <a:ext cx="731520" cy="548640"/>
           </a:xfrm>
           <a:prstGeom prst="roundRect">
             <a:avLst>
@@ -36745,7 +36586,7 @@
         <p:spPr>
           <a:xfrm>
             <a:off x="640080" y="2606040"/>
-            <a:ext cx="1280160" cy="548640"/>
+            <a:ext cx="731520" cy="548640"/>
           </a:xfrm>
           <a:prstGeom prst="rect">
             <a:avLst/>
@@ -36772,7 +36613,7 @@
                 <a:ea typeface="Alexandria" pitchFamily="34" charset="-122"/>
                 <a:cs typeface="Alexandria" pitchFamily="34" charset="-120"/>
               </a:rPr>
-              <a:t>10'</a:t>
+              <a:t>2</a:t>
             </a:r>
             <a:endParaRPr lang="en-US" sz="2400" dirty="0"/>
           </a:p>
@@ -36786,8 +36627,8 @@
         </p:nvSpPr>
         <p:spPr>
           <a:xfrm>
-            <a:off x="2103120" y="2560320"/>
-            <a:ext cx="9372600" cy="640080"/>
+            <a:off x="1554480" y="2560320"/>
+            <a:ext cx="9921240" cy="640080"/>
           </a:xfrm>
           <a:prstGeom prst="rect">
             <a:avLst/>
@@ -36851,7 +36692,7 @@
         <p:spPr>
           <a:xfrm>
             <a:off x="640080" y="3383280"/>
-            <a:ext cx="1280160" cy="548640"/>
+            <a:ext cx="731520" cy="548640"/>
           </a:xfrm>
           <a:prstGeom prst="roundRect">
             <a:avLst>
@@ -36873,7 +36714,7 @@
         <p:spPr>
           <a:xfrm>
             <a:off x="640080" y="3383280"/>
-            <a:ext cx="1280160" cy="548640"/>
+            <a:ext cx="731520" cy="548640"/>
           </a:xfrm>
           <a:prstGeom prst="rect">
             <a:avLst/>
@@ -36900,7 +36741,7 @@
                 <a:ea typeface="Alexandria" pitchFamily="34" charset="-122"/>
                 <a:cs typeface="Alexandria" pitchFamily="34" charset="-120"/>
               </a:rPr>
-              <a:t>15'</a:t>
+              <a:t>3</a:t>
             </a:r>
             <a:endParaRPr lang="en-US" sz="2400" dirty="0"/>
           </a:p>
@@ -36914,8 +36755,8 @@
         </p:nvSpPr>
         <p:spPr>
           <a:xfrm>
-            <a:off x="2103120" y="3337560"/>
-            <a:ext cx="9372600" cy="640080"/>
+            <a:off x="1554480" y="3337560"/>
+            <a:ext cx="9921240" cy="640080"/>
           </a:xfrm>
           <a:prstGeom prst="rect">
             <a:avLst/>
@@ -36979,7 +36820,7 @@
         <p:spPr>
           <a:xfrm>
             <a:off x="640080" y="4160520"/>
-            <a:ext cx="1280160" cy="548640"/>
+            <a:ext cx="731520" cy="548640"/>
           </a:xfrm>
           <a:prstGeom prst="roundRect">
             <a:avLst>
@@ -37001,7 +36842,7 @@
         <p:spPr>
           <a:xfrm>
             <a:off x="640080" y="4160520"/>
-            <a:ext cx="1280160" cy="548640"/>
+            <a:ext cx="731520" cy="548640"/>
           </a:xfrm>
           <a:prstGeom prst="rect">
             <a:avLst/>
@@ -37028,7 +36869,7 @@
                 <a:ea typeface="Alexandria" pitchFamily="34" charset="-122"/>
                 <a:cs typeface="Alexandria" pitchFamily="34" charset="-120"/>
               </a:rPr>
-              <a:t>10'</a:t>
+              <a:t>4</a:t>
             </a:r>
             <a:endParaRPr lang="en-US" sz="2400" dirty="0"/>
           </a:p>
@@ -37042,8 +36883,8 @@
         </p:nvSpPr>
         <p:spPr>
           <a:xfrm>
-            <a:off x="2103120" y="4114800"/>
-            <a:ext cx="9372600" cy="640080"/>
+            <a:off x="1554480" y="4114800"/>
+            <a:ext cx="9921240" cy="640080"/>
           </a:xfrm>
           <a:prstGeom prst="rect">
             <a:avLst/>
@@ -37070,7 +36911,7 @@
                 <a:ea typeface="Alexandria" pitchFamily="34" charset="-122"/>
                 <a:cs typeface="Alexandria" pitchFamily="34" charset="-120"/>
               </a:rPr>
-              <a:t>4–5 nhóm chia sẻ, mỗi nhóm 1 phút</a:t>
+              <a:t>4–5 nhóm chia sẻ</a:t>
             </a:r>
             <a:endParaRPr lang="en-US" sz="2800" dirty="0"/>
           </a:p>
@@ -37430,49 +37271,7 @@
       </p:sp>
       <p:sp>
         <p:nvSpPr>
-          <p:cNvPr id="8" name="Text 6"/>
-          <p:cNvSpPr txBox="1"/>
-          <p:nvPr/>
-        </p:nvSpPr>
-        <p:spPr>
-          <a:xfrm>
-            <a:off x="3840480" y="1417320"/>
-            <a:ext cx="6766560" cy="594360"/>
-          </a:xfrm>
-          <a:prstGeom prst="rect">
-            <a:avLst/>
-          </a:prstGeom>
-          <a:noFill/>
-          <a:ln/>
-        </p:spPr>
-        <p:txBody>
-          <a:bodyPr wrap="square" lIns="76200" tIns="76200" rIns="76200" bIns="76200" rtlCol="0" anchor="t"/>
-          <a:lstStyle/>
-          <a:p>
-            <a:pPr algn="l" indent="0" marL="0">
-              <a:lnSpc>
-                <a:spcPts val="3600"/>
-              </a:lnSpc>
-              <a:buNone/>
-            </a:pPr>
-            <a:r>
-              <a:rPr lang="en-US" sz="2800" b="1" dirty="0">
-                <a:solidFill>
-                  <a:srgbClr val="962B7C"/>
-                </a:solidFill>
-                <a:latin typeface="Alexandria" pitchFamily="34" charset="0"/>
-                <a:ea typeface="Alexandria" pitchFamily="34" charset="-122"/>
-                <a:cs typeface="Alexandria" pitchFamily="34" charset="-120"/>
-              </a:rPr>
-              <a:t>139–146 phút</a:t>
-            </a:r>
-            <a:endParaRPr lang="en-US" sz="2800" dirty="0"/>
-          </a:p>
-        </p:txBody>
-      </p:sp>
-      <p:sp>
-        <p:nvSpPr>
-          <p:cNvPr id="9" name="Text 0"/>
+          <p:cNvPr id="8" name="Text 0"/>
           <p:cNvSpPr/>
           <p:nvPr>
             <p:ph idx="100" type="title" hasCustomPrompt="1"/>
@@ -37480,17 +37279,17 @@
         </p:nvSpPr>
         <p:spPr>
           <a:xfrm>
-            <a:off x="3840480" y="2103120"/>
-            <a:ext cx="6766560" cy="2194560"/>
-          </a:xfrm>
-          <a:prstGeom prst="rect">
-            <a:avLst/>
-          </a:prstGeom>
-          <a:noFill/>
-          <a:ln/>
-        </p:spPr>
-        <p:txBody>
-          <a:bodyPr wrap="square" lIns="76200" tIns="76200" rIns="76200" bIns="76200" rtlCol="0" anchor="t"/>
+            <a:off x="3840480" y="2240280"/>
+            <a:ext cx="6766560" cy="2377440"/>
+          </a:xfrm>
+          <a:prstGeom prst="rect">
+            <a:avLst/>
+          </a:prstGeom>
+          <a:noFill/>
+          <a:ln/>
+        </p:spPr>
+        <p:txBody>
+          <a:bodyPr wrap="square" lIns="76200" tIns="76200" rIns="76200" bIns="76200" rtlCol="0" anchor="ctr"/>
           <a:lstStyle/>
           <a:p>
             <a:pPr algn="l" indent="0" marL="0">

</xml_diff>